<commit_message>
Add glossary and domain-collection-user diagram slides to access-setup-map
- Slide 3: "Сводный глоссарий имён" — 2x2 grid of domains/collections/personas/users
- Slide 4: "Домен → коллекция → пользователь: все связи" — full connection diagram (4 domains, 4 collections, 12 links to 8 users)

Co-Authored-By: Claude Sonnet 5 <noreply@anthropic.com>
Claude-Session: https://claude.ai/code/session_01DpSN8JwCJ3tg3JVUadr2zE
</commit_message>
<xml_diff>
--- a/docs/demo-sinaps/access-setup-map.pptx
+++ b/docs/demo-sinaps/access-setup-map.pptx
@@ -7,6 +7,8 @@
   <p:sldIdLst>
     <p:sldId id="256" r:id="rId2"/>
     <p:sldId id="257" r:id="rId3"/>
+    <p:sldId id="267" r:id="rId18"/>
+    <p:sldId id="268" r:id="rId19"/>
     <p:sldId id="258" r:id="rId4"/>
     <p:sldId id="259" r:id="rId5"/>
     <p:sldId id="260" r:id="rId6"/>
@@ -712,6 +714,182 @@
             <a:fld id="{F7021451-1387-4CA6-816F-3879F97B5CBC}" type="slidenum">
               <a:rPr lang="en-US"/>
               <a:t>11</a:t>
+            </a:fld>
+            <a:endParaRPr lang="en-US"/>
+          </a:p>
+        </p:txBody>
+      </p:sp>
+    </p:spTree>
+    <p:extLst>
+      <p:ext uri="{BB962C8B-B14F-4D97-AF65-F5344CB8AC3E}">
+        <p14:creationId xmlns:p14="http://schemas.microsoft.com/office/powerpoint/2010/main" val="1024086991"/>
+      </p:ext>
+    </p:extLst>
+  </p:cSld>
+  <p:clrMapOvr>
+    <a:masterClrMapping/>
+  </p:clrMapOvr>
+</p:notes>
+</file>
+
+<file path=ppt/notesSlides/notesSlide12.xml><?xml version="1.0" encoding="utf-8"?>
+<p:notes xmlns:a="http://schemas.openxmlformats.org/drawingml/2006/main" xmlns:r="http://schemas.openxmlformats.org/officeDocument/2006/relationships" xmlns:p="http://schemas.openxmlformats.org/presentationml/2006/main">
+  <p:cSld>
+    <p:spTree>
+      <p:nvGrpSpPr>
+        <p:cNvPr id="1" name=""/>
+        <p:cNvGrpSpPr/>
+        <p:nvPr/>
+      </p:nvGrpSpPr>
+      <p:grpSpPr>
+        <a:xfrm>
+          <a:off x="0" y="0"/>
+          <a:ext cx="0" cy="0"/>
+          <a:chOff x="0" y="0"/>
+          <a:chExt cx="0" cy="0"/>
+        </a:xfrm>
+      </p:grpSpPr>
+      <p:sp>
+        <p:nvSpPr>
+          <p:cNvPr id="2" name="Slide Image Placeholder 1"/>
+          <p:cNvSpPr>
+            <a:spLocks noGrp="1" noRot="1" noChangeAspect="1"/>
+          </p:cNvSpPr>
+          <p:nvPr>
+            <p:ph type="sldImg"/>
+          </p:nvPr>
+        </p:nvSpPr>
+        <p:spPr/>
+      </p:sp>
+      <p:sp>
+        <p:nvSpPr>
+          <p:cNvPr id="3" name="Notes Placeholder 2"/>
+          <p:cNvSpPr>
+            <a:spLocks noGrp="1"/>
+          </p:cNvSpPr>
+          <p:nvPr>
+            <p:ph type="body" idx="1"/>
+          </p:nvPr>
+        </p:nvSpPr>
+        <p:spPr/>
+        <p:txBody>
+          <a:bodyPr/>
+          <a:lstStyle/>
+          <a:p>
+            <a:r>
+              <a:rPr lang="en-US" dirty="0"/>
+              <a:t>Справочный слайд. Ничего нового не вводит — это перечень всех имён, которые понадобится ввести в платформе: домены, технические id коллекций, персоны и демо-пользователи. Держать открытым при заполнении форм, чтобы не расходились написания.</a:t>
+            </a:r>
+            <a:endParaRPr lang="en-US" dirty="0"/>
+          </a:p>
+        </p:txBody>
+      </p:sp>
+      <p:sp>
+        <p:nvSpPr>
+          <p:cNvPr id="4" name="Slide Number Placeholder 3"/>
+          <p:cNvSpPr>
+            <a:spLocks noGrp="1"/>
+          </p:cNvSpPr>
+          <p:nvPr>
+            <p:ph type="sldNum" sz="quarter" idx="10"/>
+          </p:nvPr>
+        </p:nvSpPr>
+        <p:spPr/>
+        <p:txBody>
+          <a:bodyPr/>
+          <a:lstStyle/>
+          <a:p>
+            <a:fld id="{F7021451-1387-4CA6-816F-3879F97B5CBC}" type="slidenum">
+              <a:rPr lang="en-US"/>
+              <a:t>3</a:t>
+            </a:fld>
+            <a:endParaRPr lang="en-US"/>
+          </a:p>
+        </p:txBody>
+      </p:sp>
+    </p:spTree>
+    <p:extLst>
+      <p:ext uri="{BB962C8B-B14F-4D97-AF65-F5344CB8AC3E}">
+        <p14:creationId xmlns:p14="http://schemas.microsoft.com/office/powerpoint/2010/main" val="1024086991"/>
+      </p:ext>
+    </p:extLst>
+  </p:cSld>
+  <p:clrMapOvr>
+    <a:masterClrMapping/>
+  </p:clrMapOvr>
+</p:notes>
+</file>
+
+<file path=ppt/notesSlides/notesSlide13.xml><?xml version="1.0" encoding="utf-8"?>
+<p:notes xmlns:a="http://schemas.openxmlformats.org/drawingml/2006/main" xmlns:r="http://schemas.openxmlformats.org/officeDocument/2006/relationships" xmlns:p="http://schemas.openxmlformats.org/presentationml/2006/main">
+  <p:cSld>
+    <p:spTree>
+      <p:nvGrpSpPr>
+        <p:cNvPr id="1" name=""/>
+        <p:cNvGrpSpPr/>
+        <p:nvPr/>
+      </p:nvGrpSpPr>
+      <p:grpSpPr>
+        <a:xfrm>
+          <a:off x="0" y="0"/>
+          <a:ext cx="0" cy="0"/>
+          <a:chOff x="0" y="0"/>
+          <a:chExt cx="0" cy="0"/>
+        </a:xfrm>
+      </p:grpSpPr>
+      <p:sp>
+        <p:nvSpPr>
+          <p:cNvPr id="2" name="Slide Image Placeholder 1"/>
+          <p:cNvSpPr>
+            <a:spLocks noGrp="1" noRot="1" noChangeAspect="1"/>
+          </p:cNvSpPr>
+          <p:nvPr>
+            <p:ph type="sldImg"/>
+          </p:nvPr>
+        </p:nvSpPr>
+        <p:spPr/>
+      </p:sp>
+      <p:sp>
+        <p:nvSpPr>
+          <p:cNvPr id="3" name="Notes Placeholder 2"/>
+          <p:cNvSpPr>
+            <a:spLocks noGrp="1"/>
+          </p:cNvSpPr>
+          <p:nvPr>
+            <p:ph type="body" idx="1"/>
+          </p:nvPr>
+        </p:nvSpPr>
+        <p:spPr/>
+        <p:txBody>
+          <a:bodyPr/>
+          <a:lstStyle/>
+          <a:p>
+            <a:r>
+              <a:rPr lang="en-US" dirty="0"/>
+              <a:t>Полная карта доступа к документам: 4 домена, 4 коллекции, 12 связей домен → пользователь. Персоны здесь намеренно не нарисованы — они указаны мелкой подписью, а разбираются дальше. Смирнов получает все три домена «Меридиана», у остальных — один-два.</a:t>
+            </a:r>
+            <a:endParaRPr lang="en-US" dirty="0"/>
+          </a:p>
+        </p:txBody>
+      </p:sp>
+      <p:sp>
+        <p:nvSpPr>
+          <p:cNvPr id="4" name="Slide Number Placeholder 3"/>
+          <p:cNvSpPr>
+            <a:spLocks noGrp="1"/>
+          </p:cNvSpPr>
+          <p:nvPr>
+            <p:ph type="sldNum" sz="quarter" idx="10"/>
+          </p:nvPr>
+        </p:nvSpPr>
+        <p:spPr/>
+        <p:txBody>
+          <a:bodyPr/>
+          <a:lstStyle/>
+          <a:p>
+            <a:fld id="{F7021451-1387-4CA6-816F-3879F97B5CBC}" type="slidenum">
+              <a:rPr lang="en-US"/>
+              <a:t>3</a:t>
             </a:fld>
             <a:endParaRPr lang="en-US"/>
           </a:p>
@@ -8823,6 +9001,4352 @@
 </p:sld>
 </file>
 
+<file path=ppt/slides/slide12.xml><?xml version="1.0" encoding="utf-8"?>
+<p:sld xmlns:a="http://schemas.openxmlformats.org/drawingml/2006/main" xmlns:r="http://schemas.openxmlformats.org/officeDocument/2006/relationships" xmlns:p="http://schemas.openxmlformats.org/presentationml/2006/main">
+  <p:cSld name="Slide 3a">
+    <p:spTree>
+      <p:nvGrpSpPr>
+        <p:cNvPr id="1" name=""/>
+        <p:cNvGrpSpPr/>
+        <p:nvPr/>
+      </p:nvGrpSpPr>
+      <p:grpSpPr>
+        <a:xfrm>
+          <a:off x="0" y="0"/>
+          <a:ext cx="0" cy="0"/>
+          <a:chOff x="0" y="0"/>
+          <a:chExt cx="0" cy="0"/>
+        </a:xfrm>
+      </p:grpSpPr>
+      <p:sp>
+        <p:nvSpPr>
+          <p:cNvPr id="2" name="Text 0"/>
+          <p:cNvSpPr txBox="1"/>
+          <p:nvPr/>
+        </p:nvSpPr>
+        <p:spPr>
+          <a:xfrm>
+            <a:off x="548640" y="310896"/>
+            <a:ext cx="11094415" cy="502920"/>
+          </a:xfrm>
+          <a:prstGeom prst="rect">
+            <a:avLst/>
+          </a:prstGeom>
+          <a:noFill/>
+          <a:ln/>
+        </p:spPr>
+        <p:txBody>
+          <a:bodyPr wrap="square" lIns="0" tIns="0" rIns="0" bIns="0" rtlCol="0" anchor="ctr"/>
+          <a:lstStyle/>
+          <a:p>
+            <a:pPr algn="l" indent="0" marL="0">
+              <a:buNone/>
+            </a:pPr>
+            <a:r>
+              <a:rPr lang="en-US" sz="2700" b="1" dirty="0">
+                <a:solidFill>
+                  <a:srgbClr val="16233A"/>
+                </a:solidFill>
+                <a:latin typeface="Cambria" pitchFamily="34" charset="0"/>
+                <a:ea typeface="Cambria" pitchFamily="34" charset="-122"/>
+                <a:cs typeface="Cambria" pitchFamily="34" charset="-120"/>
+              </a:rPr>
+              <a:t>Сводный глоссарий имён</a:t>
+            </a:r>
+            <a:endParaRPr lang="en-US" sz="2700" dirty="0"/>
+          </a:p>
+        </p:txBody>
+      </p:sp>
+      <p:sp>
+        <p:nvSpPr>
+          <p:cNvPr id="3" name="Text 1"/>
+          <p:cNvSpPr txBox="1"/>
+          <p:nvPr/>
+        </p:nvSpPr>
+        <p:spPr>
+          <a:xfrm>
+            <a:off x="548640" y="804672"/>
+            <a:ext cx="11094415" cy="274320"/>
+          </a:xfrm>
+          <a:prstGeom prst="rect">
+            <a:avLst/>
+          </a:prstGeom>
+          <a:noFill/>
+          <a:ln/>
+        </p:spPr>
+        <p:txBody>
+          <a:bodyPr wrap="square" lIns="0" tIns="0" rIns="0" bIns="0" rtlCol="0" anchor="t"/>
+          <a:lstStyle/>
+          <a:p>
+            <a:pPr algn="l" indent="0" marL="0">
+              <a:buNone/>
+            </a:pPr>
+            <a:r>
+              <a:rPr lang="en-US" sz="1250" dirty="0">
+                <a:solidFill>
+                  <a:srgbClr val="5E6E80"/>
+                </a:solidFill>
+                <a:latin typeface="Calibri" pitchFamily="34" charset="0"/>
+                <a:ea typeface="Calibri" pitchFamily="34" charset="-122"/>
+                <a:cs typeface="Calibri" pitchFamily="34" charset="-120"/>
+              </a:rPr>
+              <a:t>Все названия в одном месте — для быстрой сверки при настройке. Связи между ними разобраны на следующих слайдах.</a:t>
+            </a:r>
+            <a:endParaRPr lang="en-US" sz="1250" dirty="0"/>
+          </a:p>
+        </p:txBody>
+      </p:sp>
+      <p:sp>
+        <p:nvSpPr>
+          <p:cNvPr id="4" name="Shape 2"/>
+          <p:cNvSpPr/>
+          <p:nvPr/>
+        </p:nvSpPr>
+        <p:spPr>
+          <a:xfrm>
+            <a:off x="548640" y="1371600"/>
+            <a:ext cx="5341468" cy="475488"/>
+          </a:xfrm>
+          <a:prstGeom prst="roundRect">
+            <a:avLst>
+              <a:gd name="adj" fmla="val 9615"/>
+            </a:avLst>
+          </a:prstGeom>
+          <a:solidFill>
+            <a:srgbClr val="0F6E7B"/>
+          </a:solidFill>
+          <a:ln w="12700">
+            <a:solidFill>
+              <a:srgbClr val="0F6E7B"/>
+            </a:solidFill>
+            <a:prstDash val="solid"/>
+          </a:ln>
+          <a:effectLst>
+            <a:outerShdw sx="100000" sy="100000" kx="0" ky="0" algn="bl" rotWithShape="0" blurRad="76200" dist="12700" dir="5400000">
+              <a:srgbClr val="8C99A8">
+                <a:alpha val="22000"/>
+              </a:srgbClr>
+            </a:outerShdw>
+          </a:effectLst>
+        </p:spPr>
+      </p:sp>
+      <p:sp>
+        <p:nvSpPr>
+          <p:cNvPr id="5" name="Text 3"/>
+          <p:cNvSpPr txBox="1"/>
+          <p:nvPr/>
+        </p:nvSpPr>
+        <p:spPr>
+          <a:xfrm>
+            <a:off x="749808" y="1371600"/>
+            <a:ext cx="3602736" cy="475488"/>
+          </a:xfrm>
+          <a:prstGeom prst="rect">
+            <a:avLst/>
+          </a:prstGeom>
+          <a:noFill/>
+          <a:ln/>
+        </p:spPr>
+        <p:txBody>
+          <a:bodyPr wrap="square" lIns="0" tIns="0" rIns="0" bIns="0" rtlCol="0" anchor="ctr"/>
+          <a:lstStyle/>
+          <a:p>
+            <a:pPr algn="l" indent="0" marL="0">
+              <a:buNone/>
+            </a:pPr>
+            <a:r>
+              <a:rPr lang="en-US" sz="1300" b="1" dirty="0">
+                <a:solidFill>
+                  <a:srgbClr val="FFFFFF"/>
+                </a:solidFill>
+                <a:latin typeface="Calibri" pitchFamily="34" charset="0"/>
+                <a:ea typeface="Calibri" pitchFamily="34" charset="-122"/>
+                <a:cs typeface="Calibri" pitchFamily="34" charset="-120"/>
+              </a:rPr>
+              <a:t>Домены</a:t>
+            </a:r>
+            <a:endParaRPr lang="en-US" sz="1300" dirty="0"/>
+          </a:p>
+        </p:txBody>
+      </p:sp>
+      <p:sp>
+        <p:nvSpPr>
+          <p:cNvPr id="6" name="Text 4"/>
+          <p:cNvSpPr txBox="1"/>
+          <p:nvPr/>
+        </p:nvSpPr>
+        <p:spPr>
+          <a:xfrm>
+            <a:off x="4198468" y="1371600"/>
+            <a:ext cx="1490472" cy="475488"/>
+          </a:xfrm>
+          <a:prstGeom prst="rect">
+            <a:avLst/>
+          </a:prstGeom>
+          <a:noFill/>
+          <a:ln/>
+        </p:spPr>
+        <p:txBody>
+          <a:bodyPr wrap="square" lIns="0" tIns="0" rIns="0" bIns="0" rtlCol="0" anchor="ctr"/>
+          <a:lstStyle/>
+          <a:p>
+            <a:pPr algn="r" indent="0" marL="0">
+              <a:buNone/>
+            </a:pPr>
+            <a:r>
+              <a:rPr lang="en-US" sz="1300" b="1" dirty="0">
+                <a:solidFill>
+                  <a:srgbClr val="CFE0E3"/>
+                </a:solidFill>
+                <a:latin typeface="Calibri" pitchFamily="34" charset="0"/>
+                <a:ea typeface="Calibri" pitchFamily="34" charset="-122"/>
+                <a:cs typeface="Calibri" pitchFamily="34" charset="-120"/>
+              </a:rPr>
+              <a:t>4</a:t>
+            </a:r>
+            <a:endParaRPr lang="en-US" sz="1300" dirty="0"/>
+          </a:p>
+        </p:txBody>
+      </p:sp>
+      <p:sp>
+        <p:nvSpPr>
+          <p:cNvPr id="7" name="Shape 5"/>
+          <p:cNvSpPr/>
+          <p:nvPr/>
+        </p:nvSpPr>
+        <p:spPr>
+          <a:xfrm>
+            <a:off x="548640" y="1920240"/>
+            <a:ext cx="5341468" cy="1216152"/>
+          </a:xfrm>
+          <a:prstGeom prst="roundRect">
+            <a:avLst>
+              <a:gd name="adj" fmla="val 3704"/>
+            </a:avLst>
+          </a:prstGeom>
+          <a:solidFill>
+            <a:srgbClr val="E1EFF1"/>
+          </a:solidFill>
+          <a:ln w="12700">
+            <a:solidFill>
+              <a:srgbClr val="CADFE2"/>
+            </a:solidFill>
+            <a:prstDash val="solid"/>
+          </a:ln>
+        </p:spPr>
+      </p:sp>
+      <p:sp>
+        <p:nvSpPr>
+          <p:cNvPr id="8" name="Shape 6"/>
+          <p:cNvSpPr/>
+          <p:nvPr/>
+        </p:nvSpPr>
+        <p:spPr>
+          <a:xfrm>
+            <a:off x="768096" y="2123694"/>
+            <a:ext cx="68580" cy="68580"/>
+          </a:xfrm>
+          <a:prstGeom prst="ellipse">
+            <a:avLst/>
+          </a:prstGeom>
+          <a:solidFill>
+            <a:srgbClr val="0F6E7B"/>
+          </a:solidFill>
+          <a:ln w="12700">
+            <a:solidFill>
+              <a:srgbClr val="0F6E7B"/>
+            </a:solidFill>
+            <a:prstDash val="solid"/>
+          </a:ln>
+        </p:spPr>
+      </p:sp>
+      <p:sp>
+        <p:nvSpPr>
+          <p:cNvPr id="9" name="Text 7"/>
+          <p:cNvSpPr txBox="1"/>
+          <p:nvPr/>
+        </p:nvSpPr>
+        <p:spPr>
+          <a:xfrm>
+            <a:off x="932688" y="2066544"/>
+            <a:ext cx="4756252" cy="182880"/>
+          </a:xfrm>
+          <a:prstGeom prst="rect">
+            <a:avLst/>
+          </a:prstGeom>
+          <a:noFill/>
+          <a:ln/>
+        </p:spPr>
+        <p:txBody>
+          <a:bodyPr wrap="square" lIns="0" tIns="0" rIns="0" bIns="0" rtlCol="0" anchor="t"/>
+          <a:lstStyle/>
+          <a:p>
+            <a:pPr algn="l" indent="0" marL="0">
+              <a:buNone/>
+            </a:pPr>
+            <a:r>
+              <a:rPr lang="en-US" sz="1050" dirty="0">
+                <a:solidFill>
+                  <a:srgbClr val="17414A"/>
+                </a:solidFill>
+                <a:latin typeface="Calibri" pitchFamily="34" charset="0"/>
+                <a:ea typeface="Calibri" pitchFamily="34" charset="-122"/>
+                <a:cs typeface="Calibri" pitchFamily="34" charset="-120"/>
+              </a:rPr>
+              <a:t>Меридиан — Договоры</a:t>
+            </a:r>
+            <a:endParaRPr lang="en-US" sz="1050" dirty="0"/>
+          </a:p>
+        </p:txBody>
+      </p:sp>
+      <p:sp>
+        <p:nvSpPr>
+          <p:cNvPr id="10" name="Shape 8"/>
+          <p:cNvSpPr/>
+          <p:nvPr/>
+        </p:nvSpPr>
+        <p:spPr>
+          <a:xfrm>
+            <a:off x="768096" y="2370582"/>
+            <a:ext cx="68580" cy="68580"/>
+          </a:xfrm>
+          <a:prstGeom prst="ellipse">
+            <a:avLst/>
+          </a:prstGeom>
+          <a:solidFill>
+            <a:srgbClr val="0F6E7B"/>
+          </a:solidFill>
+          <a:ln w="12700">
+            <a:solidFill>
+              <a:srgbClr val="0F6E7B"/>
+            </a:solidFill>
+            <a:prstDash val="solid"/>
+          </a:ln>
+        </p:spPr>
+      </p:sp>
+      <p:sp>
+        <p:nvSpPr>
+          <p:cNvPr id="11" name="Text 9"/>
+          <p:cNvSpPr txBox="1"/>
+          <p:nvPr/>
+        </p:nvSpPr>
+        <p:spPr>
+          <a:xfrm>
+            <a:off x="932688" y="2313432"/>
+            <a:ext cx="4756252" cy="182880"/>
+          </a:xfrm>
+          <a:prstGeom prst="rect">
+            <a:avLst/>
+          </a:prstGeom>
+          <a:noFill/>
+          <a:ln/>
+        </p:spPr>
+        <p:txBody>
+          <a:bodyPr wrap="square" lIns="0" tIns="0" rIns="0" bIns="0" rtlCol="0" anchor="t"/>
+          <a:lstStyle/>
+          <a:p>
+            <a:pPr algn="l" indent="0" marL="0">
+              <a:buNone/>
+            </a:pPr>
+            <a:r>
+              <a:rPr lang="en-US" sz="1050" dirty="0">
+                <a:solidFill>
+                  <a:srgbClr val="17414A"/>
+                </a:solidFill>
+                <a:latin typeface="Calibri" pitchFamily="34" charset="0"/>
+                <a:ea typeface="Calibri" pitchFamily="34" charset="-122"/>
+                <a:cs typeface="Calibri" pitchFamily="34" charset="-120"/>
+              </a:rPr>
+              <a:t>Меридиан — Коммуникации</a:t>
+            </a:r>
+            <a:endParaRPr lang="en-US" sz="1050" dirty="0"/>
+          </a:p>
+        </p:txBody>
+      </p:sp>
+      <p:sp>
+        <p:nvSpPr>
+          <p:cNvPr id="12" name="Shape 10"/>
+          <p:cNvSpPr/>
+          <p:nvPr/>
+        </p:nvSpPr>
+        <p:spPr>
+          <a:xfrm>
+            <a:off x="768096" y="2617470"/>
+            <a:ext cx="68580" cy="68580"/>
+          </a:xfrm>
+          <a:prstGeom prst="ellipse">
+            <a:avLst/>
+          </a:prstGeom>
+          <a:solidFill>
+            <a:srgbClr val="0F6E7B"/>
+          </a:solidFill>
+          <a:ln w="12700">
+            <a:solidFill>
+              <a:srgbClr val="0F6E7B"/>
+            </a:solidFill>
+            <a:prstDash val="solid"/>
+          </a:ln>
+        </p:spPr>
+      </p:sp>
+      <p:sp>
+        <p:nvSpPr>
+          <p:cNvPr id="13" name="Text 11"/>
+          <p:cNvSpPr txBox="1"/>
+          <p:nvPr/>
+        </p:nvSpPr>
+        <p:spPr>
+          <a:xfrm>
+            <a:off x="932688" y="2560320"/>
+            <a:ext cx="4756252" cy="182880"/>
+          </a:xfrm>
+          <a:prstGeom prst="rect">
+            <a:avLst/>
+          </a:prstGeom>
+          <a:noFill/>
+          <a:ln/>
+        </p:spPr>
+        <p:txBody>
+          <a:bodyPr wrap="square" lIns="0" tIns="0" rIns="0" bIns="0" rtlCol="0" anchor="t"/>
+          <a:lstStyle/>
+          <a:p>
+            <a:pPr algn="l" indent="0" marL="0">
+              <a:buNone/>
+            </a:pPr>
+            <a:r>
+              <a:rPr lang="en-US" sz="1050" dirty="0">
+                <a:solidFill>
+                  <a:srgbClr val="17414A"/>
+                </a:solidFill>
+                <a:latin typeface="Calibri" pitchFamily="34" charset="0"/>
+                <a:ea typeface="Calibri" pitchFamily="34" charset="-122"/>
+                <a:cs typeface="Calibri" pitchFamily="34" charset="-120"/>
+              </a:rPr>
+              <a:t>Меридиан — Политики</a:t>
+            </a:r>
+            <a:endParaRPr lang="en-US" sz="1050" dirty="0"/>
+          </a:p>
+        </p:txBody>
+      </p:sp>
+      <p:sp>
+        <p:nvSpPr>
+          <p:cNvPr id="14" name="Shape 12"/>
+          <p:cNvSpPr/>
+          <p:nvPr/>
+        </p:nvSpPr>
+        <p:spPr>
+          <a:xfrm>
+            <a:off x="768096" y="2864358"/>
+            <a:ext cx="68580" cy="68580"/>
+          </a:xfrm>
+          <a:prstGeom prst="ellipse">
+            <a:avLst/>
+          </a:prstGeom>
+          <a:solidFill>
+            <a:srgbClr val="0F6E7B"/>
+          </a:solidFill>
+          <a:ln w="12700">
+            <a:solidFill>
+              <a:srgbClr val="0F6E7B"/>
+            </a:solidFill>
+            <a:prstDash val="solid"/>
+          </a:ln>
+        </p:spPr>
+      </p:sp>
+      <p:sp>
+        <p:nvSpPr>
+          <p:cNvPr id="15" name="Text 13"/>
+          <p:cNvSpPr txBox="1"/>
+          <p:nvPr/>
+        </p:nvSpPr>
+        <p:spPr>
+          <a:xfrm>
+            <a:off x="932688" y="2807208"/>
+            <a:ext cx="4756252" cy="182880"/>
+          </a:xfrm>
+          <a:prstGeom prst="rect">
+            <a:avLst/>
+          </a:prstGeom>
+          <a:noFill/>
+          <a:ln/>
+        </p:spPr>
+        <p:txBody>
+          <a:bodyPr wrap="square" lIns="0" tIns="0" rIns="0" bIns="0" rtlCol="0" anchor="t"/>
+          <a:lstStyle/>
+          <a:p>
+            <a:pPr algn="l" indent="0" marL="0">
+              <a:buNone/>
+            </a:pPr>
+            <a:r>
+              <a:rPr lang="en-US" sz="1050" dirty="0">
+                <a:solidFill>
+                  <a:srgbClr val="17414A"/>
+                </a:solidFill>
+                <a:latin typeface="Calibri" pitchFamily="34" charset="0"/>
+                <a:ea typeface="Calibri" pitchFamily="34" charset="-122"/>
+                <a:cs typeface="Calibri" pitchFamily="34" charset="-120"/>
+              </a:rPr>
+              <a:t>Полка — Операционные документы</a:t>
+            </a:r>
+            <a:endParaRPr lang="en-US" sz="1050" dirty="0"/>
+          </a:p>
+        </p:txBody>
+      </p:sp>
+      <p:sp>
+        <p:nvSpPr>
+          <p:cNvPr id="16" name="Shape 14"/>
+          <p:cNvSpPr/>
+          <p:nvPr/>
+        </p:nvSpPr>
+        <p:spPr>
+          <a:xfrm>
+            <a:off x="6301892" y="1371600"/>
+            <a:ext cx="5341468" cy="475488"/>
+          </a:xfrm>
+          <a:prstGeom prst="roundRect">
+            <a:avLst>
+              <a:gd name="adj" fmla="val 9615"/>
+            </a:avLst>
+          </a:prstGeom>
+          <a:solidFill>
+            <a:srgbClr val="0F6E7B"/>
+          </a:solidFill>
+          <a:ln w="12700">
+            <a:solidFill>
+              <a:srgbClr val="0F6E7B"/>
+            </a:solidFill>
+            <a:prstDash val="solid"/>
+          </a:ln>
+          <a:effectLst>
+            <a:outerShdw sx="100000" sy="100000" kx="0" ky="0" algn="bl" rotWithShape="0" blurRad="76200" dist="12700" dir="5400000">
+              <a:srgbClr val="8C99A8">
+                <a:alpha val="22000"/>
+              </a:srgbClr>
+            </a:outerShdw>
+          </a:effectLst>
+        </p:spPr>
+      </p:sp>
+      <p:sp>
+        <p:nvSpPr>
+          <p:cNvPr id="17" name="Text 15"/>
+          <p:cNvSpPr txBox="1"/>
+          <p:nvPr/>
+        </p:nvSpPr>
+        <p:spPr>
+          <a:xfrm>
+            <a:off x="6503060" y="1371600"/>
+            <a:ext cx="3602736" cy="475488"/>
+          </a:xfrm>
+          <a:prstGeom prst="rect">
+            <a:avLst/>
+          </a:prstGeom>
+          <a:noFill/>
+          <a:ln/>
+        </p:spPr>
+        <p:txBody>
+          <a:bodyPr wrap="square" lIns="0" tIns="0" rIns="0" bIns="0" rtlCol="0" anchor="ctr"/>
+          <a:lstStyle/>
+          <a:p>
+            <a:pPr algn="l" indent="0" marL="0">
+              <a:buNone/>
+            </a:pPr>
+            <a:r>
+              <a:rPr lang="en-US" sz="1300" b="1" dirty="0">
+                <a:solidFill>
+                  <a:srgbClr val="FFFFFF"/>
+                </a:solidFill>
+                <a:latin typeface="Calibri" pitchFamily="34" charset="0"/>
+                <a:ea typeface="Calibri" pitchFamily="34" charset="-122"/>
+                <a:cs typeface="Calibri" pitchFamily="34" charset="-120"/>
+              </a:rPr>
+              <a:t>Коллекции</a:t>
+            </a:r>
+            <a:endParaRPr lang="en-US" sz="1300" dirty="0"/>
+          </a:p>
+        </p:txBody>
+      </p:sp>
+      <p:sp>
+        <p:nvSpPr>
+          <p:cNvPr id="18" name="Text 16"/>
+          <p:cNvSpPr txBox="1"/>
+          <p:nvPr/>
+        </p:nvSpPr>
+        <p:spPr>
+          <a:xfrm>
+            <a:off x="9951720" y="1371600"/>
+            <a:ext cx="1490472" cy="475488"/>
+          </a:xfrm>
+          <a:prstGeom prst="rect">
+            <a:avLst/>
+          </a:prstGeom>
+          <a:noFill/>
+          <a:ln/>
+        </p:spPr>
+        <p:txBody>
+          <a:bodyPr wrap="square" lIns="0" tIns="0" rIns="0" bIns="0" rtlCol="0" anchor="ctr"/>
+          <a:lstStyle/>
+          <a:p>
+            <a:pPr algn="r" indent="0" marL="0">
+              <a:buNone/>
+            </a:pPr>
+            <a:r>
+              <a:rPr lang="en-US" sz="1300" b="1" dirty="0">
+                <a:solidFill>
+                  <a:srgbClr val="CFE0E3"/>
+                </a:solidFill>
+                <a:latin typeface="Calibri" pitchFamily="34" charset="0"/>
+                <a:ea typeface="Calibri" pitchFamily="34" charset="-122"/>
+                <a:cs typeface="Calibri" pitchFamily="34" charset="-120"/>
+              </a:rPr>
+              <a:t>4</a:t>
+            </a:r>
+            <a:endParaRPr lang="en-US" sz="1300" dirty="0"/>
+          </a:p>
+        </p:txBody>
+      </p:sp>
+      <p:sp>
+        <p:nvSpPr>
+          <p:cNvPr id="19" name="Shape 17"/>
+          <p:cNvSpPr/>
+          <p:nvPr/>
+        </p:nvSpPr>
+        <p:spPr>
+          <a:xfrm>
+            <a:off x="6301892" y="1920240"/>
+            <a:ext cx="5341468" cy="1216152"/>
+          </a:xfrm>
+          <a:prstGeom prst="roundRect">
+            <a:avLst>
+              <a:gd name="adj" fmla="val 3704"/>
+            </a:avLst>
+          </a:prstGeom>
+          <a:solidFill>
+            <a:srgbClr val="E1EFF1"/>
+          </a:solidFill>
+          <a:ln w="12700">
+            <a:solidFill>
+              <a:srgbClr val="CADFE2"/>
+            </a:solidFill>
+            <a:prstDash val="solid"/>
+          </a:ln>
+        </p:spPr>
+      </p:sp>
+      <p:sp>
+        <p:nvSpPr>
+          <p:cNvPr id="20" name="Shape 18"/>
+          <p:cNvSpPr/>
+          <p:nvPr/>
+        </p:nvSpPr>
+        <p:spPr>
+          <a:xfrm>
+            <a:off x="6521348" y="2123694"/>
+            <a:ext cx="68580" cy="68580"/>
+          </a:xfrm>
+          <a:prstGeom prst="ellipse">
+            <a:avLst/>
+          </a:prstGeom>
+          <a:solidFill>
+            <a:srgbClr val="0F6E7B"/>
+          </a:solidFill>
+          <a:ln w="12700">
+            <a:solidFill>
+              <a:srgbClr val="0F6E7B"/>
+            </a:solidFill>
+            <a:prstDash val="solid"/>
+          </a:ln>
+        </p:spPr>
+      </p:sp>
+      <p:sp>
+        <p:nvSpPr>
+          <p:cNvPr id="21" name="Text 19"/>
+          <p:cNvSpPr txBox="1"/>
+          <p:nvPr/>
+        </p:nvSpPr>
+        <p:spPr>
+          <a:xfrm>
+            <a:off x="6685940" y="2066544"/>
+            <a:ext cx="4756252" cy="182880"/>
+          </a:xfrm>
+          <a:prstGeom prst="rect">
+            <a:avLst/>
+          </a:prstGeom>
+          <a:noFill/>
+          <a:ln/>
+        </p:spPr>
+        <p:txBody>
+          <a:bodyPr wrap="square" lIns="0" tIns="0" rIns="0" bIns="0" rtlCol="0" anchor="t"/>
+          <a:lstStyle/>
+          <a:p>
+            <a:pPr algn="l" indent="0" marL="0">
+              <a:buNone/>
+            </a:pPr>
+            <a:r>
+              <a:rPr lang="en-US" sz="1050" dirty="0">
+                <a:solidFill>
+                  <a:srgbClr val="17414A"/>
+                </a:solidFill>
+                <a:latin typeface="Courier New" pitchFamily="34" charset="0"/>
+                <a:ea typeface="Courier New" pitchFamily="34" charset="-122"/>
+                <a:cs typeface="Courier New" pitchFamily="34" charset="-120"/>
+              </a:rPr>
+              <a:t>meridian_contracts</a:t>
+            </a:r>
+            <a:endParaRPr lang="en-US" sz="1050" dirty="0"/>
+          </a:p>
+        </p:txBody>
+      </p:sp>
+      <p:sp>
+        <p:nvSpPr>
+          <p:cNvPr id="22" name="Shape 20"/>
+          <p:cNvSpPr/>
+          <p:nvPr/>
+        </p:nvSpPr>
+        <p:spPr>
+          <a:xfrm>
+            <a:off x="6521348" y="2370582"/>
+            <a:ext cx="68580" cy="68580"/>
+          </a:xfrm>
+          <a:prstGeom prst="ellipse">
+            <a:avLst/>
+          </a:prstGeom>
+          <a:solidFill>
+            <a:srgbClr val="0F6E7B"/>
+          </a:solidFill>
+          <a:ln w="12700">
+            <a:solidFill>
+              <a:srgbClr val="0F6E7B"/>
+            </a:solidFill>
+            <a:prstDash val="solid"/>
+          </a:ln>
+        </p:spPr>
+      </p:sp>
+      <p:sp>
+        <p:nvSpPr>
+          <p:cNvPr id="23" name="Text 21"/>
+          <p:cNvSpPr txBox="1"/>
+          <p:nvPr/>
+        </p:nvSpPr>
+        <p:spPr>
+          <a:xfrm>
+            <a:off x="6685940" y="2313432"/>
+            <a:ext cx="4756252" cy="182880"/>
+          </a:xfrm>
+          <a:prstGeom prst="rect">
+            <a:avLst/>
+          </a:prstGeom>
+          <a:noFill/>
+          <a:ln/>
+        </p:spPr>
+        <p:txBody>
+          <a:bodyPr wrap="square" lIns="0" tIns="0" rIns="0" bIns="0" rtlCol="0" anchor="t"/>
+          <a:lstStyle/>
+          <a:p>
+            <a:pPr algn="l" indent="0" marL="0">
+              <a:buNone/>
+            </a:pPr>
+            <a:r>
+              <a:rPr lang="en-US" sz="1050" dirty="0">
+                <a:solidFill>
+                  <a:srgbClr val="17414A"/>
+                </a:solidFill>
+                <a:latin typeface="Courier New" pitchFamily="34" charset="0"/>
+                <a:ea typeface="Courier New" pitchFamily="34" charset="-122"/>
+                <a:cs typeface="Courier New" pitchFamily="34" charset="-120"/>
+              </a:rPr>
+              <a:t>meridian_comms</a:t>
+            </a:r>
+            <a:endParaRPr lang="en-US" sz="1050" dirty="0"/>
+          </a:p>
+        </p:txBody>
+      </p:sp>
+      <p:sp>
+        <p:nvSpPr>
+          <p:cNvPr id="24" name="Shape 22"/>
+          <p:cNvSpPr/>
+          <p:nvPr/>
+        </p:nvSpPr>
+        <p:spPr>
+          <a:xfrm>
+            <a:off x="6521348" y="2617470"/>
+            <a:ext cx="68580" cy="68580"/>
+          </a:xfrm>
+          <a:prstGeom prst="ellipse">
+            <a:avLst/>
+          </a:prstGeom>
+          <a:solidFill>
+            <a:srgbClr val="0F6E7B"/>
+          </a:solidFill>
+          <a:ln w="12700">
+            <a:solidFill>
+              <a:srgbClr val="0F6E7B"/>
+            </a:solidFill>
+            <a:prstDash val="solid"/>
+          </a:ln>
+        </p:spPr>
+      </p:sp>
+      <p:sp>
+        <p:nvSpPr>
+          <p:cNvPr id="25" name="Text 23"/>
+          <p:cNvSpPr txBox="1"/>
+          <p:nvPr/>
+        </p:nvSpPr>
+        <p:spPr>
+          <a:xfrm>
+            <a:off x="6685940" y="2560320"/>
+            <a:ext cx="4756252" cy="182880"/>
+          </a:xfrm>
+          <a:prstGeom prst="rect">
+            <a:avLst/>
+          </a:prstGeom>
+          <a:noFill/>
+          <a:ln/>
+        </p:spPr>
+        <p:txBody>
+          <a:bodyPr wrap="square" lIns="0" tIns="0" rIns="0" bIns="0" rtlCol="0" anchor="t"/>
+          <a:lstStyle/>
+          <a:p>
+            <a:pPr algn="l" indent="0" marL="0">
+              <a:buNone/>
+            </a:pPr>
+            <a:r>
+              <a:rPr lang="en-US" sz="1050" dirty="0">
+                <a:solidFill>
+                  <a:srgbClr val="17414A"/>
+                </a:solidFill>
+                <a:latin typeface="Courier New" pitchFamily="34" charset="0"/>
+                <a:ea typeface="Courier New" pitchFamily="34" charset="-122"/>
+                <a:cs typeface="Courier New" pitchFamily="34" charset="-120"/>
+              </a:rPr>
+              <a:t>meridian_policies</a:t>
+            </a:r>
+            <a:endParaRPr lang="en-US" sz="1050" dirty="0"/>
+          </a:p>
+        </p:txBody>
+      </p:sp>
+      <p:sp>
+        <p:nvSpPr>
+          <p:cNvPr id="26" name="Shape 24"/>
+          <p:cNvSpPr/>
+          <p:nvPr/>
+        </p:nvSpPr>
+        <p:spPr>
+          <a:xfrm>
+            <a:off x="6521348" y="2864358"/>
+            <a:ext cx="68580" cy="68580"/>
+          </a:xfrm>
+          <a:prstGeom prst="ellipse">
+            <a:avLst/>
+          </a:prstGeom>
+          <a:solidFill>
+            <a:srgbClr val="0F6E7B"/>
+          </a:solidFill>
+          <a:ln w="12700">
+            <a:solidFill>
+              <a:srgbClr val="0F6E7B"/>
+            </a:solidFill>
+            <a:prstDash val="solid"/>
+          </a:ln>
+        </p:spPr>
+      </p:sp>
+      <p:sp>
+        <p:nvSpPr>
+          <p:cNvPr id="27" name="Text 25"/>
+          <p:cNvSpPr txBox="1"/>
+          <p:nvPr/>
+        </p:nvSpPr>
+        <p:spPr>
+          <a:xfrm>
+            <a:off x="6685940" y="2807208"/>
+            <a:ext cx="4756252" cy="182880"/>
+          </a:xfrm>
+          <a:prstGeom prst="rect">
+            <a:avLst/>
+          </a:prstGeom>
+          <a:noFill/>
+          <a:ln/>
+        </p:spPr>
+        <p:txBody>
+          <a:bodyPr wrap="square" lIns="0" tIns="0" rIns="0" bIns="0" rtlCol="0" anchor="t"/>
+          <a:lstStyle/>
+          <a:p>
+            <a:pPr algn="l" indent="0" marL="0">
+              <a:buNone/>
+            </a:pPr>
+            <a:r>
+              <a:rPr lang="en-US" sz="1050" dirty="0">
+                <a:solidFill>
+                  <a:srgbClr val="17414A"/>
+                </a:solidFill>
+                <a:latin typeface="Courier New" pitchFamily="34" charset="0"/>
+                <a:ea typeface="Courier New" pitchFamily="34" charset="-122"/>
+                <a:cs typeface="Courier New" pitchFamily="34" charset="-120"/>
+              </a:rPr>
+              <a:t>polka_docs</a:t>
+            </a:r>
+            <a:endParaRPr lang="en-US" sz="1050" dirty="0"/>
+          </a:p>
+        </p:txBody>
+      </p:sp>
+      <p:sp>
+        <p:nvSpPr>
+          <p:cNvPr id="28" name="Shape 26"/>
+          <p:cNvSpPr/>
+          <p:nvPr/>
+        </p:nvSpPr>
+        <p:spPr>
+          <a:xfrm>
+            <a:off x="548640" y="3502152"/>
+            <a:ext cx="5341468" cy="475488"/>
+          </a:xfrm>
+          <a:prstGeom prst="roundRect">
+            <a:avLst>
+              <a:gd name="adj" fmla="val 9615"/>
+            </a:avLst>
+          </a:prstGeom>
+          <a:solidFill>
+            <a:srgbClr val="A96412"/>
+          </a:solidFill>
+          <a:ln w="12700">
+            <a:solidFill>
+              <a:srgbClr val="A96412"/>
+            </a:solidFill>
+            <a:prstDash val="solid"/>
+          </a:ln>
+          <a:effectLst>
+            <a:outerShdw sx="100000" sy="100000" kx="0" ky="0" algn="bl" rotWithShape="0" blurRad="76200" dist="12700" dir="5400000">
+              <a:srgbClr val="8C99A8">
+                <a:alpha val="22000"/>
+              </a:srgbClr>
+            </a:outerShdw>
+          </a:effectLst>
+        </p:spPr>
+      </p:sp>
+      <p:sp>
+        <p:nvSpPr>
+          <p:cNvPr id="29" name="Text 27"/>
+          <p:cNvSpPr txBox="1"/>
+          <p:nvPr/>
+        </p:nvSpPr>
+        <p:spPr>
+          <a:xfrm>
+            <a:off x="749808" y="3502152"/>
+            <a:ext cx="3602736" cy="475488"/>
+          </a:xfrm>
+          <a:prstGeom prst="rect">
+            <a:avLst/>
+          </a:prstGeom>
+          <a:noFill/>
+          <a:ln/>
+        </p:spPr>
+        <p:txBody>
+          <a:bodyPr wrap="square" lIns="0" tIns="0" rIns="0" bIns="0" rtlCol="0" anchor="ctr"/>
+          <a:lstStyle/>
+          <a:p>
+            <a:pPr algn="l" indent="0" marL="0">
+              <a:buNone/>
+            </a:pPr>
+            <a:r>
+              <a:rPr lang="en-US" sz="1300" b="1" dirty="0">
+                <a:solidFill>
+                  <a:srgbClr val="FFFFFF"/>
+                </a:solidFill>
+                <a:latin typeface="Calibri" pitchFamily="34" charset="0"/>
+                <a:ea typeface="Calibri" pitchFamily="34" charset="-122"/>
+                <a:cs typeface="Calibri" pitchFamily="34" charset="-120"/>
+              </a:rPr>
+              <a:t>Персоны</a:t>
+            </a:r>
+            <a:endParaRPr lang="en-US" sz="1300" dirty="0"/>
+          </a:p>
+        </p:txBody>
+      </p:sp>
+      <p:sp>
+        <p:nvSpPr>
+          <p:cNvPr id="30" name="Text 28"/>
+          <p:cNvSpPr txBox="1"/>
+          <p:nvPr/>
+        </p:nvSpPr>
+        <p:spPr>
+          <a:xfrm>
+            <a:off x="4198468" y="3502152"/>
+            <a:ext cx="1490472" cy="475488"/>
+          </a:xfrm>
+          <a:prstGeom prst="rect">
+            <a:avLst/>
+          </a:prstGeom>
+          <a:noFill/>
+          <a:ln/>
+        </p:spPr>
+        <p:txBody>
+          <a:bodyPr wrap="square" lIns="0" tIns="0" rIns="0" bIns="0" rtlCol="0" anchor="ctr"/>
+          <a:lstStyle/>
+          <a:p>
+            <a:pPr algn="r" indent="0" marL="0">
+              <a:buNone/>
+            </a:pPr>
+            <a:r>
+              <a:rPr lang="en-US" sz="1300" b="1" dirty="0">
+                <a:solidFill>
+                  <a:srgbClr val="F4E3C4"/>
+                </a:solidFill>
+                <a:latin typeface="Calibri" pitchFamily="34" charset="0"/>
+                <a:ea typeface="Calibri" pitchFamily="34" charset="-122"/>
+                <a:cs typeface="Calibri" pitchFamily="34" charset="-120"/>
+              </a:rPr>
+              <a:t>8</a:t>
+            </a:r>
+            <a:endParaRPr lang="en-US" sz="1300" dirty="0"/>
+          </a:p>
+        </p:txBody>
+      </p:sp>
+      <p:sp>
+        <p:nvSpPr>
+          <p:cNvPr id="31" name="Shape 29"/>
+          <p:cNvSpPr/>
+          <p:nvPr/>
+        </p:nvSpPr>
+        <p:spPr>
+          <a:xfrm>
+            <a:off x="548640" y="4050792"/>
+            <a:ext cx="5341468" cy="2203704"/>
+          </a:xfrm>
+          <a:prstGeom prst="roundRect">
+            <a:avLst>
+              <a:gd name="adj" fmla="val 3704"/>
+            </a:avLst>
+          </a:prstGeom>
+          <a:solidFill>
+            <a:srgbClr val="F7EDDD"/>
+          </a:solidFill>
+          <a:ln w="12700">
+            <a:solidFill>
+              <a:srgbClr val="E8D2AF"/>
+            </a:solidFill>
+            <a:prstDash val="solid"/>
+          </a:ln>
+        </p:spPr>
+      </p:sp>
+      <p:sp>
+        <p:nvSpPr>
+          <p:cNvPr id="32" name="Shape 30"/>
+          <p:cNvSpPr/>
+          <p:nvPr/>
+        </p:nvSpPr>
+        <p:spPr>
+          <a:xfrm>
+            <a:off x="768096" y="4254246"/>
+            <a:ext cx="68580" cy="68580"/>
+          </a:xfrm>
+          <a:prstGeom prst="ellipse">
+            <a:avLst/>
+          </a:prstGeom>
+          <a:solidFill>
+            <a:srgbClr val="A96412"/>
+          </a:solidFill>
+          <a:ln w="12700">
+            <a:solidFill>
+              <a:srgbClr val="A96412"/>
+            </a:solidFill>
+            <a:prstDash val="solid"/>
+          </a:ln>
+        </p:spPr>
+      </p:sp>
+      <p:sp>
+        <p:nvSpPr>
+          <p:cNvPr id="33" name="Text 31"/>
+          <p:cNvSpPr txBox="1"/>
+          <p:nvPr/>
+        </p:nvSpPr>
+        <p:spPr>
+          <a:xfrm>
+            <a:off x="932688" y="4197096"/>
+            <a:ext cx="4756252" cy="182880"/>
+          </a:xfrm>
+          <a:prstGeom prst="rect">
+            <a:avLst/>
+          </a:prstGeom>
+          <a:noFill/>
+          <a:ln/>
+        </p:spPr>
+        <p:txBody>
+          <a:bodyPr wrap="square" lIns="0" tIns="0" rIns="0" bIns="0" rtlCol="0" anchor="t"/>
+          <a:lstStyle/>
+          <a:p>
+            <a:pPr algn="l" indent="0" marL="0">
+              <a:buNone/>
+            </a:pPr>
+            <a:r>
+              <a:rPr lang="en-US" sz="1050" dirty="0">
+                <a:solidFill>
+                  <a:srgbClr val="7C480B"/>
+                </a:solidFill>
+                <a:latin typeface="Calibri" pitchFamily="34" charset="0"/>
+                <a:ea typeface="Calibri" pitchFamily="34" charset="-122"/>
+                <a:cs typeface="Calibri" pitchFamily="34" charset="-120"/>
+              </a:rPr>
+              <a:t>Меридиан-Гендиректор</a:t>
+            </a:r>
+            <a:endParaRPr lang="en-US" sz="1050" dirty="0"/>
+          </a:p>
+        </p:txBody>
+      </p:sp>
+      <p:sp>
+        <p:nvSpPr>
+          <p:cNvPr id="34" name="Shape 32"/>
+          <p:cNvSpPr/>
+          <p:nvPr/>
+        </p:nvSpPr>
+        <p:spPr>
+          <a:xfrm>
+            <a:off x="768096" y="4501134"/>
+            <a:ext cx="68580" cy="68580"/>
+          </a:xfrm>
+          <a:prstGeom prst="ellipse">
+            <a:avLst/>
+          </a:prstGeom>
+          <a:solidFill>
+            <a:srgbClr val="A96412"/>
+          </a:solidFill>
+          <a:ln w="12700">
+            <a:solidFill>
+              <a:srgbClr val="A96412"/>
+            </a:solidFill>
+            <a:prstDash val="solid"/>
+          </a:ln>
+        </p:spPr>
+      </p:sp>
+      <p:sp>
+        <p:nvSpPr>
+          <p:cNvPr id="35" name="Text 33"/>
+          <p:cNvSpPr txBox="1"/>
+          <p:nvPr/>
+        </p:nvSpPr>
+        <p:spPr>
+          <a:xfrm>
+            <a:off x="932688" y="4443984"/>
+            <a:ext cx="4756252" cy="182880"/>
+          </a:xfrm>
+          <a:prstGeom prst="rect">
+            <a:avLst/>
+          </a:prstGeom>
+          <a:noFill/>
+          <a:ln/>
+        </p:spPr>
+        <p:txBody>
+          <a:bodyPr wrap="square" lIns="0" tIns="0" rIns="0" bIns="0" rtlCol="0" anchor="t"/>
+          <a:lstStyle/>
+          <a:p>
+            <a:pPr algn="l" indent="0" marL="0">
+              <a:buNone/>
+            </a:pPr>
+            <a:r>
+              <a:rPr lang="en-US" sz="1050" dirty="0">
+                <a:solidFill>
+                  <a:srgbClr val="7C480B"/>
+                </a:solidFill>
+                <a:latin typeface="Calibri" pitchFamily="34" charset="0"/>
+                <a:ea typeface="Calibri" pitchFamily="34" charset="-122"/>
+                <a:cs typeface="Calibri" pitchFamily="34" charset="-120"/>
+              </a:rPr>
+              <a:t>Меридиан-HR-директор</a:t>
+            </a:r>
+            <a:endParaRPr lang="en-US" sz="1050" dirty="0"/>
+          </a:p>
+        </p:txBody>
+      </p:sp>
+      <p:sp>
+        <p:nvSpPr>
+          <p:cNvPr id="36" name="Shape 34"/>
+          <p:cNvSpPr/>
+          <p:nvPr/>
+        </p:nvSpPr>
+        <p:spPr>
+          <a:xfrm>
+            <a:off x="768096" y="4748022"/>
+            <a:ext cx="68580" cy="68580"/>
+          </a:xfrm>
+          <a:prstGeom prst="ellipse">
+            <a:avLst/>
+          </a:prstGeom>
+          <a:solidFill>
+            <a:srgbClr val="A96412"/>
+          </a:solidFill>
+          <a:ln w="12700">
+            <a:solidFill>
+              <a:srgbClr val="A96412"/>
+            </a:solidFill>
+            <a:prstDash val="solid"/>
+          </a:ln>
+        </p:spPr>
+      </p:sp>
+      <p:sp>
+        <p:nvSpPr>
+          <p:cNvPr id="37" name="Text 35"/>
+          <p:cNvSpPr txBox="1"/>
+          <p:nvPr/>
+        </p:nvSpPr>
+        <p:spPr>
+          <a:xfrm>
+            <a:off x="932688" y="4690872"/>
+            <a:ext cx="4756252" cy="182880"/>
+          </a:xfrm>
+          <a:prstGeom prst="rect">
+            <a:avLst/>
+          </a:prstGeom>
+          <a:noFill/>
+          <a:ln/>
+        </p:spPr>
+        <p:txBody>
+          <a:bodyPr wrap="square" lIns="0" tIns="0" rIns="0" bIns="0" rtlCol="0" anchor="t"/>
+          <a:lstStyle/>
+          <a:p>
+            <a:pPr algn="l" indent="0" marL="0">
+              <a:buNone/>
+            </a:pPr>
+            <a:r>
+              <a:rPr lang="en-US" sz="1050" dirty="0">
+                <a:solidFill>
+                  <a:srgbClr val="7C480B"/>
+                </a:solidFill>
+                <a:latin typeface="Calibri" pitchFamily="34" charset="0"/>
+                <a:ea typeface="Calibri" pitchFamily="34" charset="-122"/>
+                <a:cs typeface="Calibri" pitchFamily="34" charset="-120"/>
+              </a:rPr>
+              <a:t>Меридиан-Рук-продаж</a:t>
+            </a:r>
+            <a:endParaRPr lang="en-US" sz="1050" dirty="0"/>
+          </a:p>
+        </p:txBody>
+      </p:sp>
+      <p:sp>
+        <p:nvSpPr>
+          <p:cNvPr id="38" name="Shape 36"/>
+          <p:cNvSpPr/>
+          <p:nvPr/>
+        </p:nvSpPr>
+        <p:spPr>
+          <a:xfrm>
+            <a:off x="768096" y="4994910"/>
+            <a:ext cx="68580" cy="68580"/>
+          </a:xfrm>
+          <a:prstGeom prst="ellipse">
+            <a:avLst/>
+          </a:prstGeom>
+          <a:solidFill>
+            <a:srgbClr val="A96412"/>
+          </a:solidFill>
+          <a:ln w="12700">
+            <a:solidFill>
+              <a:srgbClr val="A96412"/>
+            </a:solidFill>
+            <a:prstDash val="solid"/>
+          </a:ln>
+        </p:spPr>
+      </p:sp>
+      <p:sp>
+        <p:nvSpPr>
+          <p:cNvPr id="39" name="Text 37"/>
+          <p:cNvSpPr txBox="1"/>
+          <p:nvPr/>
+        </p:nvSpPr>
+        <p:spPr>
+          <a:xfrm>
+            <a:off x="932688" y="4937760"/>
+            <a:ext cx="4756252" cy="182880"/>
+          </a:xfrm>
+          <a:prstGeom prst="rect">
+            <a:avLst/>
+          </a:prstGeom>
+          <a:noFill/>
+          <a:ln/>
+        </p:spPr>
+        <p:txBody>
+          <a:bodyPr wrap="square" lIns="0" tIns="0" rIns="0" bIns="0" rtlCol="0" anchor="t"/>
+          <a:lstStyle/>
+          <a:p>
+            <a:pPr algn="l" indent="0" marL="0">
+              <a:buNone/>
+            </a:pPr>
+            <a:r>
+              <a:rPr lang="en-US" sz="1050" dirty="0">
+                <a:solidFill>
+                  <a:srgbClr val="7C480B"/>
+                </a:solidFill>
+                <a:latin typeface="Calibri" pitchFamily="34" charset="0"/>
+                <a:ea typeface="Calibri" pitchFamily="34" charset="-122"/>
+                <a:cs typeface="Calibri" pitchFamily="34" charset="-120"/>
+              </a:rPr>
+              <a:t>Меридиан-Финаналитик</a:t>
+            </a:r>
+            <a:endParaRPr lang="en-US" sz="1050" dirty="0"/>
+          </a:p>
+        </p:txBody>
+      </p:sp>
+      <p:sp>
+        <p:nvSpPr>
+          <p:cNvPr id="40" name="Shape 38"/>
+          <p:cNvSpPr/>
+          <p:nvPr/>
+        </p:nvSpPr>
+        <p:spPr>
+          <a:xfrm>
+            <a:off x="768096" y="5241798"/>
+            <a:ext cx="68580" cy="68580"/>
+          </a:xfrm>
+          <a:prstGeom prst="ellipse">
+            <a:avLst/>
+          </a:prstGeom>
+          <a:solidFill>
+            <a:srgbClr val="A96412"/>
+          </a:solidFill>
+          <a:ln w="12700">
+            <a:solidFill>
+              <a:srgbClr val="A96412"/>
+            </a:solidFill>
+            <a:prstDash val="solid"/>
+          </a:ln>
+        </p:spPr>
+      </p:sp>
+      <p:sp>
+        <p:nvSpPr>
+          <p:cNvPr id="41" name="Text 39"/>
+          <p:cNvSpPr txBox="1"/>
+          <p:nvPr/>
+        </p:nvSpPr>
+        <p:spPr>
+          <a:xfrm>
+            <a:off x="932688" y="5184648"/>
+            <a:ext cx="4756252" cy="182880"/>
+          </a:xfrm>
+          <a:prstGeom prst="rect">
+            <a:avLst/>
+          </a:prstGeom>
+          <a:noFill/>
+          <a:ln/>
+        </p:spPr>
+        <p:txBody>
+          <a:bodyPr wrap="square" lIns="0" tIns="0" rIns="0" bIns="0" rtlCol="0" anchor="t"/>
+          <a:lstStyle/>
+          <a:p>
+            <a:pPr algn="l" indent="0" marL="0">
+              <a:buNone/>
+            </a:pPr>
+            <a:r>
+              <a:rPr lang="en-US" sz="1050" dirty="0">
+                <a:solidFill>
+                  <a:srgbClr val="7C480B"/>
+                </a:solidFill>
+                <a:latin typeface="Calibri" pitchFamily="34" charset="0"/>
+                <a:ea typeface="Calibri" pitchFamily="34" charset="-122"/>
+                <a:cs typeface="Calibri" pitchFamily="34" charset="-120"/>
+              </a:rPr>
+              <a:t>Меридиан-Юрист</a:t>
+            </a:r>
+            <a:endParaRPr lang="en-US" sz="1050" dirty="0"/>
+          </a:p>
+        </p:txBody>
+      </p:sp>
+      <p:sp>
+        <p:nvSpPr>
+          <p:cNvPr id="42" name="Shape 40"/>
+          <p:cNvSpPr/>
+          <p:nvPr/>
+        </p:nvSpPr>
+        <p:spPr>
+          <a:xfrm>
+            <a:off x="768096" y="5488686"/>
+            <a:ext cx="68580" cy="68580"/>
+          </a:xfrm>
+          <a:prstGeom prst="ellipse">
+            <a:avLst/>
+          </a:prstGeom>
+          <a:solidFill>
+            <a:srgbClr val="A96412"/>
+          </a:solidFill>
+          <a:ln w="12700">
+            <a:solidFill>
+              <a:srgbClr val="A96412"/>
+            </a:solidFill>
+            <a:prstDash val="solid"/>
+          </a:ln>
+        </p:spPr>
+      </p:sp>
+      <p:sp>
+        <p:nvSpPr>
+          <p:cNvPr id="43" name="Text 41"/>
+          <p:cNvSpPr txBox="1"/>
+          <p:nvPr/>
+        </p:nvSpPr>
+        <p:spPr>
+          <a:xfrm>
+            <a:off x="932688" y="5431536"/>
+            <a:ext cx="4756252" cy="182880"/>
+          </a:xfrm>
+          <a:prstGeom prst="rect">
+            <a:avLst/>
+          </a:prstGeom>
+          <a:noFill/>
+          <a:ln/>
+        </p:spPr>
+        <p:txBody>
+          <a:bodyPr wrap="square" lIns="0" tIns="0" rIns="0" bIns="0" rtlCol="0" anchor="t"/>
+          <a:lstStyle/>
+          <a:p>
+            <a:pPr algn="l" indent="0" marL="0">
+              <a:buNone/>
+            </a:pPr>
+            <a:r>
+              <a:rPr lang="en-US" sz="1050" dirty="0">
+                <a:solidFill>
+                  <a:srgbClr val="7C480B"/>
+                </a:solidFill>
+                <a:latin typeface="Calibri" pitchFamily="34" charset="0"/>
+                <a:ea typeface="Calibri" pitchFamily="34" charset="-122"/>
+                <a:cs typeface="Calibri" pitchFamily="34" charset="-120"/>
+              </a:rPr>
+              <a:t>Меридиан-ИБ</a:t>
+            </a:r>
+            <a:endParaRPr lang="en-US" sz="1050" dirty="0"/>
+          </a:p>
+        </p:txBody>
+      </p:sp>
+      <p:sp>
+        <p:nvSpPr>
+          <p:cNvPr id="44" name="Shape 42"/>
+          <p:cNvSpPr/>
+          <p:nvPr/>
+        </p:nvSpPr>
+        <p:spPr>
+          <a:xfrm>
+            <a:off x="768096" y="5735574"/>
+            <a:ext cx="68580" cy="68580"/>
+          </a:xfrm>
+          <a:prstGeom prst="ellipse">
+            <a:avLst/>
+          </a:prstGeom>
+          <a:solidFill>
+            <a:srgbClr val="A96412"/>
+          </a:solidFill>
+          <a:ln w="12700">
+            <a:solidFill>
+              <a:srgbClr val="A96412"/>
+            </a:solidFill>
+            <a:prstDash val="solid"/>
+          </a:ln>
+        </p:spPr>
+      </p:sp>
+      <p:sp>
+        <p:nvSpPr>
+          <p:cNvPr id="45" name="Text 43"/>
+          <p:cNvSpPr txBox="1"/>
+          <p:nvPr/>
+        </p:nvSpPr>
+        <p:spPr>
+          <a:xfrm>
+            <a:off x="932688" y="5678424"/>
+            <a:ext cx="4756252" cy="182880"/>
+          </a:xfrm>
+          <a:prstGeom prst="rect">
+            <a:avLst/>
+          </a:prstGeom>
+          <a:noFill/>
+          <a:ln/>
+        </p:spPr>
+        <p:txBody>
+          <a:bodyPr wrap="square" lIns="0" tIns="0" rIns="0" bIns="0" rtlCol="0" anchor="t"/>
+          <a:lstStyle/>
+          <a:p>
+            <a:pPr algn="l" indent="0" marL="0">
+              <a:buNone/>
+            </a:pPr>
+            <a:r>
+              <a:rPr lang="en-US" sz="1050" dirty="0">
+                <a:solidFill>
+                  <a:srgbClr val="7C480B"/>
+                </a:solidFill>
+                <a:latin typeface="Calibri" pitchFamily="34" charset="0"/>
+                <a:ea typeface="Calibri" pitchFamily="34" charset="-122"/>
+                <a:cs typeface="Calibri" pitchFamily="34" charset="-120"/>
+              </a:rPr>
+              <a:t>Полка-Сервис</a:t>
+            </a:r>
+            <a:endParaRPr lang="en-US" sz="1050" dirty="0"/>
+          </a:p>
+        </p:txBody>
+      </p:sp>
+      <p:sp>
+        <p:nvSpPr>
+          <p:cNvPr id="46" name="Shape 44"/>
+          <p:cNvSpPr/>
+          <p:nvPr/>
+        </p:nvSpPr>
+        <p:spPr>
+          <a:xfrm>
+            <a:off x="768096" y="5982462"/>
+            <a:ext cx="68580" cy="68580"/>
+          </a:xfrm>
+          <a:prstGeom prst="ellipse">
+            <a:avLst/>
+          </a:prstGeom>
+          <a:solidFill>
+            <a:srgbClr val="A96412"/>
+          </a:solidFill>
+          <a:ln w="12700">
+            <a:solidFill>
+              <a:srgbClr val="A96412"/>
+            </a:solidFill>
+            <a:prstDash val="solid"/>
+          </a:ln>
+        </p:spPr>
+      </p:sp>
+      <p:sp>
+        <p:nvSpPr>
+          <p:cNvPr id="47" name="Text 45"/>
+          <p:cNvSpPr txBox="1"/>
+          <p:nvPr/>
+        </p:nvSpPr>
+        <p:spPr>
+          <a:xfrm>
+            <a:off x="932688" y="5925312"/>
+            <a:ext cx="4756252" cy="182880"/>
+          </a:xfrm>
+          <a:prstGeom prst="rect">
+            <a:avLst/>
+          </a:prstGeom>
+          <a:noFill/>
+          <a:ln/>
+        </p:spPr>
+        <p:txBody>
+          <a:bodyPr wrap="square" lIns="0" tIns="0" rIns="0" bIns="0" rtlCol="0" anchor="t"/>
+          <a:lstStyle/>
+          <a:p>
+            <a:pPr algn="l" indent="0" marL="0">
+              <a:buNone/>
+            </a:pPr>
+            <a:r>
+              <a:rPr lang="en-US" sz="1050" dirty="0">
+                <a:solidFill>
+                  <a:srgbClr val="7C480B"/>
+                </a:solidFill>
+                <a:latin typeface="Calibri" pitchFamily="34" charset="0"/>
+                <a:ea typeface="Calibri" pitchFamily="34" charset="-122"/>
+                <a:cs typeface="Calibri" pitchFamily="34" charset="-120"/>
+              </a:rPr>
+              <a:t>Полка-Продукт</a:t>
+            </a:r>
+            <a:endParaRPr lang="en-US" sz="1050" dirty="0"/>
+          </a:p>
+        </p:txBody>
+      </p:sp>
+      <p:sp>
+        <p:nvSpPr>
+          <p:cNvPr id="48" name="Shape 46"/>
+          <p:cNvSpPr/>
+          <p:nvPr/>
+        </p:nvSpPr>
+        <p:spPr>
+          <a:xfrm>
+            <a:off x="6301892" y="3502152"/>
+            <a:ext cx="5341468" cy="475488"/>
+          </a:xfrm>
+          <a:prstGeom prst="roundRect">
+            <a:avLst>
+              <a:gd name="adj" fmla="val 9615"/>
+            </a:avLst>
+          </a:prstGeom>
+          <a:solidFill>
+            <a:srgbClr val="A96412"/>
+          </a:solidFill>
+          <a:ln w="12700">
+            <a:solidFill>
+              <a:srgbClr val="A96412"/>
+            </a:solidFill>
+            <a:prstDash val="solid"/>
+          </a:ln>
+          <a:effectLst>
+            <a:outerShdw sx="100000" sy="100000" kx="0" ky="0" algn="bl" rotWithShape="0" blurRad="76200" dist="12700" dir="5400000">
+              <a:srgbClr val="8C99A8">
+                <a:alpha val="22000"/>
+              </a:srgbClr>
+            </a:outerShdw>
+          </a:effectLst>
+        </p:spPr>
+      </p:sp>
+      <p:sp>
+        <p:nvSpPr>
+          <p:cNvPr id="49" name="Text 47"/>
+          <p:cNvSpPr txBox="1"/>
+          <p:nvPr/>
+        </p:nvSpPr>
+        <p:spPr>
+          <a:xfrm>
+            <a:off x="6503060" y="3502152"/>
+            <a:ext cx="3602736" cy="475488"/>
+          </a:xfrm>
+          <a:prstGeom prst="rect">
+            <a:avLst/>
+          </a:prstGeom>
+          <a:noFill/>
+          <a:ln/>
+        </p:spPr>
+        <p:txBody>
+          <a:bodyPr wrap="square" lIns="0" tIns="0" rIns="0" bIns="0" rtlCol="0" anchor="ctr"/>
+          <a:lstStyle/>
+          <a:p>
+            <a:pPr algn="l" indent="0" marL="0">
+              <a:buNone/>
+            </a:pPr>
+            <a:r>
+              <a:rPr lang="en-US" sz="1300" b="1" dirty="0">
+                <a:solidFill>
+                  <a:srgbClr val="FFFFFF"/>
+                </a:solidFill>
+                <a:latin typeface="Calibri" pitchFamily="34" charset="0"/>
+                <a:ea typeface="Calibri" pitchFamily="34" charset="-122"/>
+                <a:cs typeface="Calibri" pitchFamily="34" charset="-120"/>
+              </a:rPr>
+              <a:t>Пользователи</a:t>
+            </a:r>
+            <a:endParaRPr lang="en-US" sz="1300" dirty="0"/>
+          </a:p>
+        </p:txBody>
+      </p:sp>
+      <p:sp>
+        <p:nvSpPr>
+          <p:cNvPr id="50" name="Text 48"/>
+          <p:cNvSpPr txBox="1"/>
+          <p:nvPr/>
+        </p:nvSpPr>
+        <p:spPr>
+          <a:xfrm>
+            <a:off x="9951720" y="3502152"/>
+            <a:ext cx="1490472" cy="475488"/>
+          </a:xfrm>
+          <a:prstGeom prst="rect">
+            <a:avLst/>
+          </a:prstGeom>
+          <a:noFill/>
+          <a:ln/>
+        </p:spPr>
+        <p:txBody>
+          <a:bodyPr wrap="square" lIns="0" tIns="0" rIns="0" bIns="0" rtlCol="0" anchor="ctr"/>
+          <a:lstStyle/>
+          <a:p>
+            <a:pPr algn="r" indent="0" marL="0">
+              <a:buNone/>
+            </a:pPr>
+            <a:r>
+              <a:rPr lang="en-US" sz="1300" b="1" dirty="0">
+                <a:solidFill>
+                  <a:srgbClr val="F4E3C4"/>
+                </a:solidFill>
+                <a:latin typeface="Calibri" pitchFamily="34" charset="0"/>
+                <a:ea typeface="Calibri" pitchFamily="34" charset="-122"/>
+                <a:cs typeface="Calibri" pitchFamily="34" charset="-120"/>
+              </a:rPr>
+              <a:t>8</a:t>
+            </a:r>
+            <a:endParaRPr lang="en-US" sz="1300" dirty="0"/>
+          </a:p>
+        </p:txBody>
+      </p:sp>
+      <p:sp>
+        <p:nvSpPr>
+          <p:cNvPr id="51" name="Shape 49"/>
+          <p:cNvSpPr/>
+          <p:nvPr/>
+        </p:nvSpPr>
+        <p:spPr>
+          <a:xfrm>
+            <a:off x="6301892" y="4050792"/>
+            <a:ext cx="5341468" cy="2203704"/>
+          </a:xfrm>
+          <a:prstGeom prst="roundRect">
+            <a:avLst>
+              <a:gd name="adj" fmla="val 3704"/>
+            </a:avLst>
+          </a:prstGeom>
+          <a:solidFill>
+            <a:srgbClr val="F7EDDD"/>
+          </a:solidFill>
+          <a:ln w="12700">
+            <a:solidFill>
+              <a:srgbClr val="E8D2AF"/>
+            </a:solidFill>
+            <a:prstDash val="solid"/>
+          </a:ln>
+        </p:spPr>
+      </p:sp>
+      <p:sp>
+        <p:nvSpPr>
+          <p:cNvPr id="52" name="Shape 50"/>
+          <p:cNvSpPr/>
+          <p:nvPr/>
+        </p:nvSpPr>
+        <p:spPr>
+          <a:xfrm>
+            <a:off x="6521348" y="4254246"/>
+            <a:ext cx="68580" cy="68580"/>
+          </a:xfrm>
+          <a:prstGeom prst="ellipse">
+            <a:avLst/>
+          </a:prstGeom>
+          <a:solidFill>
+            <a:srgbClr val="A96412"/>
+          </a:solidFill>
+          <a:ln w="12700">
+            <a:solidFill>
+              <a:srgbClr val="A96412"/>
+            </a:solidFill>
+            <a:prstDash val="solid"/>
+          </a:ln>
+        </p:spPr>
+      </p:sp>
+      <p:sp>
+        <p:nvSpPr>
+          <p:cNvPr id="53" name="Text 51"/>
+          <p:cNvSpPr txBox="1"/>
+          <p:nvPr/>
+        </p:nvSpPr>
+        <p:spPr>
+          <a:xfrm>
+            <a:off x="6685940" y="4197096"/>
+            <a:ext cx="4756252" cy="182880"/>
+          </a:xfrm>
+          <a:prstGeom prst="rect">
+            <a:avLst/>
+          </a:prstGeom>
+          <a:noFill/>
+          <a:ln/>
+        </p:spPr>
+        <p:txBody>
+          <a:bodyPr wrap="square" lIns="0" tIns="0" rIns="0" bIns="0" rtlCol="0" anchor="t"/>
+          <a:lstStyle/>
+          <a:p>
+            <a:pPr algn="l" indent="0" marL="0">
+              <a:buNone/>
+            </a:pPr>
+            <a:r>
+              <a:rPr lang="en-US" sz="1050" dirty="0">
+                <a:solidFill>
+                  <a:srgbClr val="7C480B"/>
+                </a:solidFill>
+                <a:latin typeface="Calibri" pitchFamily="34" charset="0"/>
+                <a:ea typeface="Calibri" pitchFamily="34" charset="-122"/>
+                <a:cs typeface="Calibri" pitchFamily="34" charset="-120"/>
+              </a:rPr>
+              <a:t>Смирнов Г.А. (E-001)</a:t>
+            </a:r>
+            <a:endParaRPr lang="en-US" sz="1050" dirty="0"/>
+          </a:p>
+        </p:txBody>
+      </p:sp>
+      <p:sp>
+        <p:nvSpPr>
+          <p:cNvPr id="54" name="Shape 52"/>
+          <p:cNvSpPr/>
+          <p:nvPr/>
+        </p:nvSpPr>
+        <p:spPr>
+          <a:xfrm>
+            <a:off x="6521348" y="4501134"/>
+            <a:ext cx="68580" cy="68580"/>
+          </a:xfrm>
+          <a:prstGeom prst="ellipse">
+            <a:avLst/>
+          </a:prstGeom>
+          <a:solidFill>
+            <a:srgbClr val="A96412"/>
+          </a:solidFill>
+          <a:ln w="12700">
+            <a:solidFill>
+              <a:srgbClr val="A96412"/>
+            </a:solidFill>
+            <a:prstDash val="solid"/>
+          </a:ln>
+        </p:spPr>
+      </p:sp>
+      <p:sp>
+        <p:nvSpPr>
+          <p:cNvPr id="55" name="Text 53"/>
+          <p:cNvSpPr txBox="1"/>
+          <p:nvPr/>
+        </p:nvSpPr>
+        <p:spPr>
+          <a:xfrm>
+            <a:off x="6685940" y="4443984"/>
+            <a:ext cx="4756252" cy="182880"/>
+          </a:xfrm>
+          <a:prstGeom prst="rect">
+            <a:avLst/>
+          </a:prstGeom>
+          <a:noFill/>
+          <a:ln/>
+        </p:spPr>
+        <p:txBody>
+          <a:bodyPr wrap="square" lIns="0" tIns="0" rIns="0" bIns="0" rtlCol="0" anchor="t"/>
+          <a:lstStyle/>
+          <a:p>
+            <a:pPr algn="l" indent="0" marL="0">
+              <a:buNone/>
+            </a:pPr>
+            <a:r>
+              <a:rPr lang="en-US" sz="1050" dirty="0">
+                <a:solidFill>
+                  <a:srgbClr val="7C480B"/>
+                </a:solidFill>
+                <a:latin typeface="Calibri" pitchFamily="34" charset="0"/>
+                <a:ea typeface="Calibri" pitchFamily="34" charset="-122"/>
+                <a:cs typeface="Calibri" pitchFamily="34" charset="-120"/>
+              </a:rPr>
+              <a:t>Иванова Т.Н. (E-003)</a:t>
+            </a:r>
+            <a:endParaRPr lang="en-US" sz="1050" dirty="0"/>
+          </a:p>
+        </p:txBody>
+      </p:sp>
+      <p:sp>
+        <p:nvSpPr>
+          <p:cNvPr id="56" name="Shape 54"/>
+          <p:cNvSpPr/>
+          <p:nvPr/>
+        </p:nvSpPr>
+        <p:spPr>
+          <a:xfrm>
+            <a:off x="6521348" y="4748022"/>
+            <a:ext cx="68580" cy="68580"/>
+          </a:xfrm>
+          <a:prstGeom prst="ellipse">
+            <a:avLst/>
+          </a:prstGeom>
+          <a:solidFill>
+            <a:srgbClr val="A96412"/>
+          </a:solidFill>
+          <a:ln w="12700">
+            <a:solidFill>
+              <a:srgbClr val="A96412"/>
+            </a:solidFill>
+            <a:prstDash val="solid"/>
+          </a:ln>
+        </p:spPr>
+      </p:sp>
+      <p:sp>
+        <p:nvSpPr>
+          <p:cNvPr id="57" name="Text 55"/>
+          <p:cNvSpPr txBox="1"/>
+          <p:nvPr/>
+        </p:nvSpPr>
+        <p:spPr>
+          <a:xfrm>
+            <a:off x="6685940" y="4690872"/>
+            <a:ext cx="4756252" cy="182880"/>
+          </a:xfrm>
+          <a:prstGeom prst="rect">
+            <a:avLst/>
+          </a:prstGeom>
+          <a:noFill/>
+          <a:ln/>
+        </p:spPr>
+        <p:txBody>
+          <a:bodyPr wrap="square" lIns="0" tIns="0" rIns="0" bIns="0" rtlCol="0" anchor="t"/>
+          <a:lstStyle/>
+          <a:p>
+            <a:pPr algn="l" indent="0" marL="0">
+              <a:buNone/>
+            </a:pPr>
+            <a:r>
+              <a:rPr lang="en-US" sz="1050" dirty="0">
+                <a:solidFill>
+                  <a:srgbClr val="7C480B"/>
+                </a:solidFill>
+                <a:latin typeface="Calibri" pitchFamily="34" charset="0"/>
+                <a:ea typeface="Calibri" pitchFamily="34" charset="-122"/>
+                <a:cs typeface="Calibri" pitchFamily="34" charset="-120"/>
+              </a:rPr>
+              <a:t>Петров А.В. (E-006)</a:t>
+            </a:r>
+            <a:endParaRPr lang="en-US" sz="1050" dirty="0"/>
+          </a:p>
+        </p:txBody>
+      </p:sp>
+      <p:sp>
+        <p:nvSpPr>
+          <p:cNvPr id="58" name="Shape 56"/>
+          <p:cNvSpPr/>
+          <p:nvPr/>
+        </p:nvSpPr>
+        <p:spPr>
+          <a:xfrm>
+            <a:off x="6521348" y="4994910"/>
+            <a:ext cx="68580" cy="68580"/>
+          </a:xfrm>
+          <a:prstGeom prst="ellipse">
+            <a:avLst/>
+          </a:prstGeom>
+          <a:solidFill>
+            <a:srgbClr val="A96412"/>
+          </a:solidFill>
+          <a:ln w="12700">
+            <a:solidFill>
+              <a:srgbClr val="A96412"/>
+            </a:solidFill>
+            <a:prstDash val="solid"/>
+          </a:ln>
+        </p:spPr>
+      </p:sp>
+      <p:sp>
+        <p:nvSpPr>
+          <p:cNvPr id="59" name="Text 57"/>
+          <p:cNvSpPr txBox="1"/>
+          <p:nvPr/>
+        </p:nvSpPr>
+        <p:spPr>
+          <a:xfrm>
+            <a:off x="6685940" y="4937760"/>
+            <a:ext cx="4756252" cy="182880"/>
+          </a:xfrm>
+          <a:prstGeom prst="rect">
+            <a:avLst/>
+          </a:prstGeom>
+          <a:noFill/>
+          <a:ln/>
+        </p:spPr>
+        <p:txBody>
+          <a:bodyPr wrap="square" lIns="0" tIns="0" rIns="0" bIns="0" rtlCol="0" anchor="t"/>
+          <a:lstStyle/>
+          <a:p>
+            <a:pPr algn="l" indent="0" marL="0">
+              <a:buNone/>
+            </a:pPr>
+            <a:r>
+              <a:rPr lang="en-US" sz="1050" dirty="0">
+                <a:solidFill>
+                  <a:srgbClr val="7C480B"/>
+                </a:solidFill>
+                <a:latin typeface="Calibri" pitchFamily="34" charset="0"/>
+                <a:ea typeface="Calibri" pitchFamily="34" charset="-122"/>
+                <a:cs typeface="Calibri" pitchFamily="34" charset="-120"/>
+              </a:rPr>
+              <a:t>Сидоров К.Л. (E-011)</a:t>
+            </a:r>
+            <a:endParaRPr lang="en-US" sz="1050" dirty="0"/>
+          </a:p>
+        </p:txBody>
+      </p:sp>
+      <p:sp>
+        <p:nvSpPr>
+          <p:cNvPr id="60" name="Shape 58"/>
+          <p:cNvSpPr/>
+          <p:nvPr/>
+        </p:nvSpPr>
+        <p:spPr>
+          <a:xfrm>
+            <a:off x="6521348" y="5241798"/>
+            <a:ext cx="68580" cy="68580"/>
+          </a:xfrm>
+          <a:prstGeom prst="ellipse">
+            <a:avLst/>
+          </a:prstGeom>
+          <a:solidFill>
+            <a:srgbClr val="A96412"/>
+          </a:solidFill>
+          <a:ln w="12700">
+            <a:solidFill>
+              <a:srgbClr val="A96412"/>
+            </a:solidFill>
+            <a:prstDash val="solid"/>
+          </a:ln>
+        </p:spPr>
+      </p:sp>
+      <p:sp>
+        <p:nvSpPr>
+          <p:cNvPr id="61" name="Text 59"/>
+          <p:cNvSpPr txBox="1"/>
+          <p:nvPr/>
+        </p:nvSpPr>
+        <p:spPr>
+          <a:xfrm>
+            <a:off x="6685940" y="5184648"/>
+            <a:ext cx="4756252" cy="182880"/>
+          </a:xfrm>
+          <a:prstGeom prst="rect">
+            <a:avLst/>
+          </a:prstGeom>
+          <a:noFill/>
+          <a:ln/>
+        </p:spPr>
+        <p:txBody>
+          <a:bodyPr wrap="square" lIns="0" tIns="0" rIns="0" bIns="0" rtlCol="0" anchor="t"/>
+          <a:lstStyle/>
+          <a:p>
+            <a:pPr algn="l" indent="0" marL="0">
+              <a:buNone/>
+            </a:pPr>
+            <a:r>
+              <a:rPr lang="en-US" sz="1050" dirty="0">
+                <a:solidFill>
+                  <a:srgbClr val="7C480B"/>
+                </a:solidFill>
+                <a:latin typeface="Calibri" pitchFamily="34" charset="0"/>
+                <a:ea typeface="Calibri" pitchFamily="34" charset="-122"/>
+                <a:cs typeface="Calibri" pitchFamily="34" charset="-120"/>
+              </a:rPr>
+              <a:t>Кузнецова А.Д. (E-005)</a:t>
+            </a:r>
+            <a:endParaRPr lang="en-US" sz="1050" dirty="0"/>
+          </a:p>
+        </p:txBody>
+      </p:sp>
+      <p:sp>
+        <p:nvSpPr>
+          <p:cNvPr id="62" name="Shape 60"/>
+          <p:cNvSpPr/>
+          <p:nvPr/>
+        </p:nvSpPr>
+        <p:spPr>
+          <a:xfrm>
+            <a:off x="6521348" y="5488686"/>
+            <a:ext cx="68580" cy="68580"/>
+          </a:xfrm>
+          <a:prstGeom prst="ellipse">
+            <a:avLst/>
+          </a:prstGeom>
+          <a:solidFill>
+            <a:srgbClr val="A96412"/>
+          </a:solidFill>
+          <a:ln w="12700">
+            <a:solidFill>
+              <a:srgbClr val="A96412"/>
+            </a:solidFill>
+            <a:prstDash val="solid"/>
+          </a:ln>
+        </p:spPr>
+      </p:sp>
+      <p:sp>
+        <p:nvSpPr>
+          <p:cNvPr id="63" name="Text 61"/>
+          <p:cNvSpPr txBox="1"/>
+          <p:nvPr/>
+        </p:nvSpPr>
+        <p:spPr>
+          <a:xfrm>
+            <a:off x="6685940" y="5431536"/>
+            <a:ext cx="4756252" cy="182880"/>
+          </a:xfrm>
+          <a:prstGeom prst="rect">
+            <a:avLst/>
+          </a:prstGeom>
+          <a:noFill/>
+          <a:ln/>
+        </p:spPr>
+        <p:txBody>
+          <a:bodyPr wrap="square" lIns="0" tIns="0" rIns="0" bIns="0" rtlCol="0" anchor="t"/>
+          <a:lstStyle/>
+          <a:p>
+            <a:pPr algn="l" indent="0" marL="0">
+              <a:buNone/>
+            </a:pPr>
+            <a:r>
+              <a:rPr lang="en-US" sz="1050" dirty="0">
+                <a:solidFill>
+                  <a:srgbClr val="7C480B"/>
+                </a:solidFill>
+                <a:latin typeface="Calibri" pitchFamily="34" charset="0"/>
+                <a:ea typeface="Calibri" pitchFamily="34" charset="-122"/>
+                <a:cs typeface="Calibri" pitchFamily="34" charset="-120"/>
+              </a:rPr>
+              <a:t>Соколов И.Р. (E-004)</a:t>
+            </a:r>
+            <a:endParaRPr lang="en-US" sz="1050" dirty="0"/>
+          </a:p>
+        </p:txBody>
+      </p:sp>
+      <p:sp>
+        <p:nvSpPr>
+          <p:cNvPr id="64" name="Shape 62"/>
+          <p:cNvSpPr/>
+          <p:nvPr/>
+        </p:nvSpPr>
+        <p:spPr>
+          <a:xfrm>
+            <a:off x="6521348" y="5735574"/>
+            <a:ext cx="68580" cy="68580"/>
+          </a:xfrm>
+          <a:prstGeom prst="ellipse">
+            <a:avLst/>
+          </a:prstGeom>
+          <a:solidFill>
+            <a:srgbClr val="A96412"/>
+          </a:solidFill>
+          <a:ln w="12700">
+            <a:solidFill>
+              <a:srgbClr val="A96412"/>
+            </a:solidFill>
+            <a:prstDash val="solid"/>
+          </a:ln>
+        </p:spPr>
+      </p:sp>
+      <p:sp>
+        <p:nvSpPr>
+          <p:cNvPr id="65" name="Text 63"/>
+          <p:cNvSpPr txBox="1"/>
+          <p:nvPr/>
+        </p:nvSpPr>
+        <p:spPr>
+          <a:xfrm>
+            <a:off x="6685940" y="5678424"/>
+            <a:ext cx="4756252" cy="182880"/>
+          </a:xfrm>
+          <a:prstGeom prst="rect">
+            <a:avLst/>
+          </a:prstGeom>
+          <a:noFill/>
+          <a:ln/>
+        </p:spPr>
+        <p:txBody>
+          <a:bodyPr wrap="square" lIns="0" tIns="0" rIns="0" bIns="0" rtlCol="0" anchor="t"/>
+          <a:lstStyle/>
+          <a:p>
+            <a:pPr algn="l" indent="0" marL="0">
+              <a:buNone/>
+            </a:pPr>
+            <a:r>
+              <a:rPr lang="en-US" sz="1050" dirty="0">
+                <a:solidFill>
+                  <a:srgbClr val="7C480B"/>
+                </a:solidFill>
+                <a:latin typeface="Calibri" pitchFamily="34" charset="0"/>
+                <a:ea typeface="Calibri" pitchFamily="34" charset="-122"/>
+                <a:cs typeface="Calibri" pitchFamily="34" charset="-120"/>
+              </a:rPr>
+              <a:t>клиентский сервис (Полка)</a:t>
+            </a:r>
+            <a:endParaRPr lang="en-US" sz="1050" dirty="0"/>
+          </a:p>
+        </p:txBody>
+      </p:sp>
+      <p:sp>
+        <p:nvSpPr>
+          <p:cNvPr id="66" name="Shape 64"/>
+          <p:cNvSpPr/>
+          <p:nvPr/>
+        </p:nvSpPr>
+        <p:spPr>
+          <a:xfrm>
+            <a:off x="6521348" y="5982462"/>
+            <a:ext cx="68580" cy="68580"/>
+          </a:xfrm>
+          <a:prstGeom prst="ellipse">
+            <a:avLst/>
+          </a:prstGeom>
+          <a:solidFill>
+            <a:srgbClr val="A96412"/>
+          </a:solidFill>
+          <a:ln w="12700">
+            <a:solidFill>
+              <a:srgbClr val="A96412"/>
+            </a:solidFill>
+            <a:prstDash val="solid"/>
+          </a:ln>
+        </p:spPr>
+      </p:sp>
+      <p:sp>
+        <p:nvSpPr>
+          <p:cNvPr id="67" name="Text 65"/>
+          <p:cNvSpPr txBox="1"/>
+          <p:nvPr/>
+        </p:nvSpPr>
+        <p:spPr>
+          <a:xfrm>
+            <a:off x="6685940" y="5925312"/>
+            <a:ext cx="4756252" cy="182880"/>
+          </a:xfrm>
+          <a:prstGeom prst="rect">
+            <a:avLst/>
+          </a:prstGeom>
+          <a:noFill/>
+          <a:ln/>
+        </p:spPr>
+        <p:txBody>
+          <a:bodyPr wrap="square" lIns="0" tIns="0" rIns="0" bIns="0" rtlCol="0" anchor="t"/>
+          <a:lstStyle/>
+          <a:p>
+            <a:pPr algn="l" indent="0" marL="0">
+              <a:buNone/>
+            </a:pPr>
+            <a:r>
+              <a:rPr lang="en-US" sz="1050" dirty="0">
+                <a:solidFill>
+                  <a:srgbClr val="7C480B"/>
+                </a:solidFill>
+                <a:latin typeface="Calibri" pitchFamily="34" charset="0"/>
+                <a:ea typeface="Calibri" pitchFamily="34" charset="-122"/>
+                <a:cs typeface="Calibri" pitchFamily="34" charset="-120"/>
+              </a:rPr>
+              <a:t>категорийный менеджер (Полка)</a:t>
+            </a:r>
+            <a:endParaRPr lang="en-US" sz="1050" dirty="0"/>
+          </a:p>
+        </p:txBody>
+      </p:sp>
+    </p:spTree>
+  </p:cSld>
+  <p:clrMapOvr>
+    <a:masterClrMapping/>
+  </p:clrMapOvr>
+</p:sld>
+</file>
+
+<file path=ppt/slides/slide13.xml><?xml version="1.0" encoding="utf-8"?>
+<p:sld xmlns:a="http://schemas.openxmlformats.org/drawingml/2006/main" xmlns:r="http://schemas.openxmlformats.org/officeDocument/2006/relationships" xmlns:p="http://schemas.openxmlformats.org/presentationml/2006/main">
+  <p:cSld name="Slide 3b">
+    <p:spTree>
+      <p:nvGrpSpPr>
+        <p:cNvPr id="1" name=""/>
+        <p:cNvGrpSpPr/>
+        <p:nvPr/>
+      </p:nvGrpSpPr>
+      <p:grpSpPr>
+        <a:xfrm>
+          <a:off x="0" y="0"/>
+          <a:ext cx="0" cy="0"/>
+          <a:chOff x="0" y="0"/>
+          <a:chExt cx="0" cy="0"/>
+        </a:xfrm>
+      </p:grpSpPr>
+      <p:sp>
+        <p:nvSpPr>
+          <p:cNvPr id="2" name="Text 0"/>
+          <p:cNvSpPr txBox="1"/>
+          <p:nvPr/>
+        </p:nvSpPr>
+        <p:spPr>
+          <a:xfrm>
+            <a:off x="548640" y="274320"/>
+            <a:ext cx="11091672" cy="457200"/>
+          </a:xfrm>
+          <a:prstGeom prst="rect">
+            <a:avLst/>
+          </a:prstGeom>
+          <a:noFill/>
+          <a:ln/>
+        </p:spPr>
+        <p:txBody>
+          <a:bodyPr wrap="square" lIns="0" tIns="0" rIns="0" bIns="0" rtlCol="0" anchor="ctr"/>
+          <a:lstStyle/>
+          <a:p>
+            <a:pPr algn="l" indent="0" marL="0">
+              <a:buNone/>
+            </a:pPr>
+            <a:r>
+              <a:rPr lang="en-US" sz="2700" b="1" dirty="0">
+                <a:solidFill>
+                  <a:srgbClr val="16233A"/>
+                </a:solidFill>
+                <a:latin typeface="Cambria" pitchFamily="34" charset="0"/>
+                <a:ea typeface="Cambria" pitchFamily="34" charset="-122"/>
+                <a:cs typeface="Cambria" pitchFamily="34" charset="-120"/>
+              </a:rPr>
+              <a:t>Домен → коллекция → пользователь: все связи</a:t>
+            </a:r>
+            <a:endParaRPr lang="en-US" sz="2700" dirty="0"/>
+          </a:p>
+        </p:txBody>
+      </p:sp>
+      <p:sp>
+        <p:nvSpPr>
+          <p:cNvPr id="3" name="Text 1"/>
+          <p:cNvSpPr txBox="1"/>
+          <p:nvPr/>
+        </p:nvSpPr>
+        <p:spPr>
+          <a:xfrm>
+            <a:off x="548640" y="768096"/>
+            <a:ext cx="11091672" cy="457200"/>
+          </a:xfrm>
+          <a:prstGeom prst="rect">
+            <a:avLst/>
+          </a:prstGeom>
+          <a:noFill/>
+          <a:ln/>
+        </p:spPr>
+        <p:txBody>
+          <a:bodyPr wrap="square" lIns="0" tIns="0" rIns="0" bIns="0" rtlCol="0" anchor="t"/>
+          <a:lstStyle/>
+          <a:p>
+            <a:pPr algn="l" indent="0" marL="0">
+              <a:buNone/>
+            </a:pPr>
+            <a:r>
+              <a:rPr lang="en-US" sz="1250" dirty="0">
+                <a:solidFill>
+                  <a:srgbClr val="5E6E80"/>
+                </a:solidFill>
+                <a:latin typeface="Calibri" pitchFamily="34" charset="0"/>
+                <a:ea typeface="Calibri" pitchFamily="34" charset="-122"/>
+                <a:cs typeface="Calibri" pitchFamily="34" charset="-120"/>
+              </a:rPr>
+              <a:t>Кто из демо-пользователей получает какой корпус документов: 4 домена, 4 коллекции, 12 связей. Один пользователь может получить несколько доменов — у Смирнова их три.</a:t>
+            </a:r>
+            <a:endParaRPr lang="en-US" sz="1250" dirty="0"/>
+          </a:p>
+        </p:txBody>
+      </p:sp>
+      <p:sp>
+        <p:nvSpPr>
+          <p:cNvPr id="4" name="Text 2"/>
+          <p:cNvSpPr txBox="1"/>
+          <p:nvPr/>
+        </p:nvSpPr>
+        <p:spPr>
+          <a:xfrm>
+            <a:off x="548640" y="1280160"/>
+            <a:ext cx="2834640" cy="182880"/>
+          </a:xfrm>
+          <a:prstGeom prst="rect">
+            <a:avLst/>
+          </a:prstGeom>
+          <a:noFill/>
+          <a:ln/>
+        </p:spPr>
+        <p:txBody>
+          <a:bodyPr wrap="square" lIns="0" tIns="0" rIns="0" bIns="0" rtlCol="0" anchor="t"/>
+          <a:lstStyle/>
+          <a:p>
+            <a:pPr algn="l" indent="0" marL="0">
+              <a:buNone/>
+            </a:pPr>
+            <a:r>
+              <a:rPr lang="en-US" sz="850" b="1" dirty="0">
+                <a:solidFill>
+                  <a:srgbClr val="0F6E7B"/>
+                </a:solidFill>
+                <a:latin typeface="Calibri" pitchFamily="34" charset="0"/>
+                <a:ea typeface="Calibri" pitchFamily="34" charset="-122"/>
+                <a:cs typeface="Calibri" pitchFamily="34" charset="-120"/>
+              </a:rPr>
+              <a:t>ДОМЕН  →  КОЛЛЕКЦИЯ</a:t>
+            </a:r>
+            <a:endParaRPr lang="en-US" sz="850" dirty="0"/>
+          </a:p>
+        </p:txBody>
+      </p:sp>
+      <p:sp>
+        <p:nvSpPr>
+          <p:cNvPr id="5" name="Text 3"/>
+          <p:cNvSpPr txBox="1"/>
+          <p:nvPr/>
+        </p:nvSpPr>
+        <p:spPr>
+          <a:xfrm>
+            <a:off x="7059168" y="1280160"/>
+            <a:ext cx="4581144" cy="182880"/>
+          </a:xfrm>
+          <a:prstGeom prst="rect">
+            <a:avLst/>
+          </a:prstGeom>
+          <a:noFill/>
+          <a:ln/>
+        </p:spPr>
+        <p:txBody>
+          <a:bodyPr wrap="square" lIns="0" tIns="0" rIns="0" bIns="0" rtlCol="0" anchor="t"/>
+          <a:lstStyle/>
+          <a:p>
+            <a:pPr algn="l" indent="0" marL="0">
+              <a:buNone/>
+            </a:pPr>
+            <a:r>
+              <a:rPr lang="en-US" sz="850" b="1" dirty="0">
+                <a:solidFill>
+                  <a:srgbClr val="0F6E7B"/>
+                </a:solidFill>
+                <a:latin typeface="Calibri" pitchFamily="34" charset="0"/>
+                <a:ea typeface="Calibri" pitchFamily="34" charset="-122"/>
+                <a:cs typeface="Calibri" pitchFamily="34" charset="-120"/>
+              </a:rPr>
+              <a:t>ПОЛЬЗОВАТЕЛИ · 8</a:t>
+            </a:r>
+            <a:endParaRPr lang="en-US" sz="850" dirty="0"/>
+          </a:p>
+        </p:txBody>
+      </p:sp>
+      <p:sp>
+        <p:nvSpPr>
+          <p:cNvPr id="6" name="Text 4"/>
+          <p:cNvSpPr txBox="1"/>
+          <p:nvPr/>
+        </p:nvSpPr>
+        <p:spPr>
+          <a:xfrm>
+            <a:off x="9528048" y="1280160"/>
+            <a:ext cx="1911096" cy="182880"/>
+          </a:xfrm>
+          <a:prstGeom prst="rect">
+            <a:avLst/>
+          </a:prstGeom>
+          <a:noFill/>
+          <a:ln/>
+        </p:spPr>
+        <p:txBody>
+          <a:bodyPr wrap="square" lIns="0" tIns="0" rIns="0" bIns="0" rtlCol="0" anchor="t"/>
+          <a:lstStyle/>
+          <a:p>
+            <a:pPr algn="r" indent="0" marL="0">
+              <a:buNone/>
+            </a:pPr>
+            <a:r>
+              <a:rPr lang="en-US" sz="850" b="1" dirty="0">
+                <a:solidFill>
+                  <a:srgbClr val="A96412"/>
+                </a:solidFill>
+                <a:latin typeface="Calibri" pitchFamily="34" charset="0"/>
+                <a:ea typeface="Calibri" pitchFamily="34" charset="-122"/>
+                <a:cs typeface="Calibri" pitchFamily="34" charset="-120"/>
+              </a:rPr>
+              <a:t>ПЕРСОНА</a:t>
+            </a:r>
+            <a:endParaRPr lang="en-US" sz="850" dirty="0"/>
+          </a:p>
+        </p:txBody>
+      </p:sp>
+      <p:sp>
+        <p:nvSpPr>
+          <p:cNvPr id="7" name="Line 5"/>
+          <p:cNvSpPr/>
+          <p:nvPr/>
+        </p:nvSpPr>
+        <p:spPr>
+          <a:xfrm>
+            <a:off x="3383280" y="2286000"/>
+            <a:ext cx="3675888" cy="530352"/>
+          </a:xfrm>
+          <a:prstGeom prst="line">
+            <a:avLst/>
+          </a:prstGeom>
+          <a:noFill/>
+          <a:ln w="15875">
+            <a:solidFill>
+              <a:srgbClr val="0F6E7B"/>
+            </a:solidFill>
+            <a:prstDash val="solid"/>
+            <a:tailEnd type="triangle"/>
+          </a:ln>
+        </p:spPr>
+      </p:sp>
+      <p:sp>
+        <p:nvSpPr>
+          <p:cNvPr id="8" name="Line 6"/>
+          <p:cNvSpPr/>
+          <p:nvPr/>
+        </p:nvSpPr>
+        <p:spPr>
+          <a:xfrm flipV="1">
+            <a:off x="3383280" y="2916936"/>
+            <a:ext cx="3675888" cy="576072"/>
+          </a:xfrm>
+          <a:prstGeom prst="line">
+            <a:avLst/>
+          </a:prstGeom>
+          <a:noFill/>
+          <a:ln w="15875">
+            <a:solidFill>
+              <a:srgbClr val="0F6E7B"/>
+            </a:solidFill>
+            <a:prstDash val="solid"/>
+            <a:tailEnd type="triangle"/>
+          </a:ln>
+        </p:spPr>
+      </p:sp>
+      <p:sp>
+        <p:nvSpPr>
+          <p:cNvPr id="9" name="Line 7"/>
+          <p:cNvSpPr/>
+          <p:nvPr/>
+        </p:nvSpPr>
+        <p:spPr>
+          <a:xfrm flipV="1">
+            <a:off x="3383280" y="3017520"/>
+            <a:ext cx="3675888" cy="1682496"/>
+          </a:xfrm>
+          <a:prstGeom prst="line">
+            <a:avLst/>
+          </a:prstGeom>
+          <a:noFill/>
+          <a:ln w="15875">
+            <a:solidFill>
+              <a:srgbClr val="0F6E7B"/>
+            </a:solidFill>
+            <a:prstDash val="solid"/>
+            <a:tailEnd type="triangle"/>
+          </a:ln>
+        </p:spPr>
+      </p:sp>
+      <p:sp>
+        <p:nvSpPr>
+          <p:cNvPr id="10" name="Line 8"/>
+          <p:cNvSpPr/>
+          <p:nvPr/>
+        </p:nvSpPr>
+        <p:spPr>
+          <a:xfrm>
+            <a:off x="3383280" y="2286000"/>
+            <a:ext cx="3675888" cy="1165860"/>
+          </a:xfrm>
+          <a:prstGeom prst="line">
+            <a:avLst/>
+          </a:prstGeom>
+          <a:noFill/>
+          <a:ln w="15875">
+            <a:solidFill>
+              <a:srgbClr val="0F6E7B"/>
+            </a:solidFill>
+            <a:prstDash val="solid"/>
+            <a:tailEnd type="triangle"/>
+          </a:ln>
+        </p:spPr>
+      </p:sp>
+      <p:sp>
+        <p:nvSpPr>
+          <p:cNvPr id="11" name="Line 9"/>
+          <p:cNvSpPr/>
+          <p:nvPr/>
+        </p:nvSpPr>
+        <p:spPr>
+          <a:xfrm flipV="1">
+            <a:off x="3383280" y="3552444"/>
+            <a:ext cx="3675888" cy="1147572"/>
+          </a:xfrm>
+          <a:prstGeom prst="line">
+            <a:avLst/>
+          </a:prstGeom>
+          <a:noFill/>
+          <a:ln w="15875">
+            <a:solidFill>
+              <a:srgbClr val="0F6E7B"/>
+            </a:solidFill>
+            <a:prstDash val="solid"/>
+            <a:tailEnd type="triangle"/>
+          </a:ln>
+        </p:spPr>
+      </p:sp>
+      <p:sp>
+        <p:nvSpPr>
+          <p:cNvPr id="12" name="Line 10"/>
+          <p:cNvSpPr/>
+          <p:nvPr/>
+        </p:nvSpPr>
+        <p:spPr>
+          <a:xfrm flipV="1">
+            <a:off x="3383280" y="1746504"/>
+            <a:ext cx="3675888" cy="1746504"/>
+          </a:xfrm>
+          <a:prstGeom prst="line">
+            <a:avLst/>
+          </a:prstGeom>
+          <a:noFill/>
+          <a:ln w="15875">
+            <a:solidFill>
+              <a:srgbClr val="0F6E7B"/>
+            </a:solidFill>
+            <a:prstDash val="solid"/>
+            <a:tailEnd type="triangle"/>
+          </a:ln>
+        </p:spPr>
+      </p:sp>
+      <p:sp>
+        <p:nvSpPr>
+          <p:cNvPr id="13" name="Line 11"/>
+          <p:cNvSpPr/>
+          <p:nvPr/>
+        </p:nvSpPr>
+        <p:spPr>
+          <a:xfrm flipV="1">
+            <a:off x="3383280" y="2281428"/>
+            <a:ext cx="3675888" cy="1211580"/>
+          </a:xfrm>
+          <a:prstGeom prst="line">
+            <a:avLst/>
+          </a:prstGeom>
+          <a:noFill/>
+          <a:ln w="15875">
+            <a:solidFill>
+              <a:srgbClr val="0F6E7B"/>
+            </a:solidFill>
+            <a:prstDash val="solid"/>
+            <a:tailEnd type="triangle"/>
+          </a:ln>
+        </p:spPr>
+      </p:sp>
+      <p:sp>
+        <p:nvSpPr>
+          <p:cNvPr id="14" name="Line 12"/>
+          <p:cNvSpPr/>
+          <p:nvPr/>
+        </p:nvSpPr>
+        <p:spPr>
+          <a:xfrm flipV="1">
+            <a:off x="3383280" y="2382012"/>
+            <a:ext cx="3675888" cy="2318004"/>
+          </a:xfrm>
+          <a:prstGeom prst="line">
+            <a:avLst/>
+          </a:prstGeom>
+          <a:noFill/>
+          <a:ln w="15875">
+            <a:solidFill>
+              <a:srgbClr val="0F6E7B"/>
+            </a:solidFill>
+            <a:prstDash val="solid"/>
+            <a:tailEnd type="triangle"/>
+          </a:ln>
+        </p:spPr>
+      </p:sp>
+      <p:sp>
+        <p:nvSpPr>
+          <p:cNvPr id="15" name="Line 13"/>
+          <p:cNvSpPr/>
+          <p:nvPr/>
+        </p:nvSpPr>
+        <p:spPr>
+          <a:xfrm flipV="1">
+            <a:off x="3383280" y="4087368"/>
+            <a:ext cx="3675888" cy="612648"/>
+          </a:xfrm>
+          <a:prstGeom prst="line">
+            <a:avLst/>
+          </a:prstGeom>
+          <a:noFill/>
+          <a:ln w="15875">
+            <a:solidFill>
+              <a:srgbClr val="0F6E7B"/>
+            </a:solidFill>
+            <a:prstDash val="solid"/>
+            <a:tailEnd type="triangle"/>
+          </a:ln>
+        </p:spPr>
+      </p:sp>
+      <p:sp>
+        <p:nvSpPr>
+          <p:cNvPr id="16" name="Line 14"/>
+          <p:cNvSpPr/>
+          <p:nvPr/>
+        </p:nvSpPr>
+        <p:spPr>
+          <a:xfrm flipV="1">
+            <a:off x="3383280" y="4672584"/>
+            <a:ext cx="3675888" cy="27432"/>
+          </a:xfrm>
+          <a:prstGeom prst="line">
+            <a:avLst/>
+          </a:prstGeom>
+          <a:noFill/>
+          <a:ln w="15875">
+            <a:solidFill>
+              <a:srgbClr val="0F6E7B"/>
+            </a:solidFill>
+            <a:prstDash val="solid"/>
+            <a:tailEnd type="triangle"/>
+          </a:ln>
+        </p:spPr>
+      </p:sp>
+      <p:sp>
+        <p:nvSpPr>
+          <p:cNvPr id="17" name="Line 15"/>
+          <p:cNvSpPr/>
+          <p:nvPr/>
+        </p:nvSpPr>
+        <p:spPr>
+          <a:xfrm flipV="1">
+            <a:off x="3383280" y="5257800"/>
+            <a:ext cx="3675888" cy="649224"/>
+          </a:xfrm>
+          <a:prstGeom prst="line">
+            <a:avLst/>
+          </a:prstGeom>
+          <a:noFill/>
+          <a:ln w="15875">
+            <a:solidFill>
+              <a:srgbClr val="0F6E7B"/>
+            </a:solidFill>
+            <a:prstDash val="solid"/>
+            <a:tailEnd type="triangle"/>
+          </a:ln>
+        </p:spPr>
+      </p:sp>
+      <p:sp>
+        <p:nvSpPr>
+          <p:cNvPr id="18" name="Line 16"/>
+          <p:cNvSpPr/>
+          <p:nvPr/>
+        </p:nvSpPr>
+        <p:spPr>
+          <a:xfrm flipV="1">
+            <a:off x="3383280" y="5843016"/>
+            <a:ext cx="3675888" cy="64008"/>
+          </a:xfrm>
+          <a:prstGeom prst="line">
+            <a:avLst/>
+          </a:prstGeom>
+          <a:noFill/>
+          <a:ln w="15875">
+            <a:solidFill>
+              <a:srgbClr val="0F6E7B"/>
+            </a:solidFill>
+            <a:prstDash val="solid"/>
+            <a:tailEnd type="triangle"/>
+          </a:ln>
+        </p:spPr>
+      </p:sp>
+      <p:sp>
+        <p:nvSpPr>
+          <p:cNvPr id="19" name="Shape 17"/>
+          <p:cNvSpPr/>
+          <p:nvPr/>
+        </p:nvSpPr>
+        <p:spPr>
+          <a:xfrm>
+            <a:off x="548640" y="1517904"/>
+            <a:ext cx="2834640" cy="475488"/>
+          </a:xfrm>
+          <a:prstGeom prst="roundRect">
+            <a:avLst>
+              <a:gd name="adj" fmla="val 9615"/>
+            </a:avLst>
+          </a:prstGeom>
+          <a:solidFill>
+            <a:srgbClr val="0F6E7B"/>
+          </a:solidFill>
+          <a:ln w="12700">
+            <a:solidFill>
+              <a:srgbClr val="0F6E7B"/>
+            </a:solidFill>
+            <a:prstDash val="solid"/>
+          </a:ln>
+          <a:effectLst>
+            <a:outerShdw sx="100000" sy="100000" kx="0" ky="0" algn="bl" rotWithShape="0" blurRad="76200" dist="12700" dir="5400000">
+              <a:srgbClr val="8C99A8">
+                <a:alpha val="22000"/>
+              </a:srgbClr>
+            </a:outerShdw>
+          </a:effectLst>
+        </p:spPr>
+      </p:sp>
+      <p:sp>
+        <p:nvSpPr>
+          <p:cNvPr id="20" name="Text 18"/>
+          <p:cNvSpPr txBox="1"/>
+          <p:nvPr/>
+        </p:nvSpPr>
+        <p:spPr>
+          <a:xfrm>
+            <a:off x="713232" y="1517904"/>
+            <a:ext cx="2505456" cy="475488"/>
+          </a:xfrm>
+          <a:prstGeom prst="rect">
+            <a:avLst/>
+          </a:prstGeom>
+          <a:noFill/>
+          <a:ln/>
+        </p:spPr>
+        <p:txBody>
+          <a:bodyPr wrap="square" lIns="0" tIns="0" rIns="0" bIns="0" rtlCol="0" anchor="ctr"/>
+          <a:lstStyle/>
+          <a:p>
+            <a:pPr algn="l" indent="0" marL="0">
+              <a:lnSpc>
+                <a:spcPct val="100000"/>
+              </a:lnSpc>
+              <a:buNone/>
+            </a:pPr>
+            <a:r>
+              <a:rPr lang="en-US" sz="1100" b="1" dirty="0">
+                <a:solidFill>
+                  <a:srgbClr val="FFFFFF"/>
+                </a:solidFill>
+                <a:latin typeface="Calibri" pitchFamily="34" charset="0"/>
+                <a:ea typeface="Calibri" pitchFamily="34" charset="-122"/>
+                <a:cs typeface="Calibri" pitchFamily="34" charset="-120"/>
+              </a:rPr>
+              <a:t>Меридиан — Договоры</a:t>
+            </a:r>
+            <a:endParaRPr lang="en-US" sz="1100" dirty="0"/>
+          </a:p>
+        </p:txBody>
+      </p:sp>
+      <p:sp>
+        <p:nvSpPr>
+          <p:cNvPr id="21" name="Line 19"/>
+          <p:cNvSpPr/>
+          <p:nvPr/>
+        </p:nvSpPr>
+        <p:spPr>
+          <a:xfrm>
+            <a:off x="1965960" y="1993392"/>
+            <a:ext cx="0" cy="128016"/>
+          </a:xfrm>
+          <a:prstGeom prst="line">
+            <a:avLst/>
+          </a:prstGeom>
+          <a:noFill/>
+          <a:ln w="19050">
+            <a:solidFill>
+              <a:srgbClr val="0F6E7B"/>
+            </a:solidFill>
+            <a:prstDash val="solid"/>
+            <a:tailEnd type="triangle"/>
+          </a:ln>
+        </p:spPr>
+      </p:sp>
+      <p:sp>
+        <p:nvSpPr>
+          <p:cNvPr id="22" name="Shape 20"/>
+          <p:cNvSpPr/>
+          <p:nvPr/>
+        </p:nvSpPr>
+        <p:spPr>
+          <a:xfrm>
+            <a:off x="548640" y="2121408"/>
+            <a:ext cx="2834640" cy="329184"/>
+          </a:xfrm>
+          <a:prstGeom prst="roundRect">
+            <a:avLst>
+              <a:gd name="adj" fmla="val 12500"/>
+            </a:avLst>
+          </a:prstGeom>
+          <a:solidFill>
+            <a:srgbClr val="FFFFFF"/>
+          </a:solidFill>
+          <a:ln w="15875">
+            <a:solidFill>
+              <a:srgbClr val="0F6E7B"/>
+            </a:solidFill>
+            <a:prstDash val="solid"/>
+          </a:ln>
+        </p:spPr>
+      </p:sp>
+      <p:sp>
+        <p:nvSpPr>
+          <p:cNvPr id="23" name="Text 21"/>
+          <p:cNvSpPr txBox="1"/>
+          <p:nvPr/>
+        </p:nvSpPr>
+        <p:spPr>
+          <a:xfrm>
+            <a:off x="548640" y="2121408"/>
+            <a:ext cx="2834640" cy="329184"/>
+          </a:xfrm>
+          <a:prstGeom prst="rect">
+            <a:avLst/>
+          </a:prstGeom>
+          <a:noFill/>
+          <a:ln/>
+        </p:spPr>
+        <p:txBody>
+          <a:bodyPr wrap="square" lIns="0" tIns="0" rIns="0" bIns="0" rtlCol="0" anchor="ctr"/>
+          <a:lstStyle/>
+          <a:p>
+            <a:pPr algn="ctr" indent="0" marL="0">
+              <a:buNone/>
+            </a:pPr>
+            <a:r>
+              <a:rPr lang="en-US" sz="900" dirty="0">
+                <a:solidFill>
+                  <a:srgbClr val="5E6E80"/>
+                </a:solidFill>
+                <a:latin typeface="Calibri" pitchFamily="34" charset="0"/>
+                <a:ea typeface="Calibri" pitchFamily="34" charset="-122"/>
+                <a:cs typeface="Calibri" pitchFamily="34" charset="-120"/>
+              </a:rPr>
+              <a:t>коллекция  </a:t>
+            </a:r>
+            <a:r>
+              <a:rPr lang="en-US" sz="1050" b="1" dirty="0">
+                <a:solidFill>
+                  <a:srgbClr val="0F6E7B"/>
+                </a:solidFill>
+                <a:latin typeface="Courier New" pitchFamily="34" charset="0"/>
+                <a:ea typeface="Courier New" pitchFamily="34" charset="-122"/>
+                <a:cs typeface="Courier New" pitchFamily="34" charset="-120"/>
+              </a:rPr>
+              <a:t>meridian_contracts</a:t>
+            </a:r>
+            <a:endParaRPr lang="en-US" sz="1050" dirty="0"/>
+          </a:p>
+        </p:txBody>
+      </p:sp>
+      <p:sp>
+        <p:nvSpPr>
+          <p:cNvPr id="24" name="Shape 22"/>
+          <p:cNvSpPr/>
+          <p:nvPr/>
+        </p:nvSpPr>
+        <p:spPr>
+          <a:xfrm>
+            <a:off x="548640" y="2724912"/>
+            <a:ext cx="2834640" cy="475488"/>
+          </a:xfrm>
+          <a:prstGeom prst="roundRect">
+            <a:avLst>
+              <a:gd name="adj" fmla="val 9615"/>
+            </a:avLst>
+          </a:prstGeom>
+          <a:solidFill>
+            <a:srgbClr val="0F6E7B"/>
+          </a:solidFill>
+          <a:ln w="12700">
+            <a:solidFill>
+              <a:srgbClr val="0F6E7B"/>
+            </a:solidFill>
+            <a:prstDash val="solid"/>
+          </a:ln>
+          <a:effectLst>
+            <a:outerShdw sx="100000" sy="100000" kx="0" ky="0" algn="bl" rotWithShape="0" blurRad="76200" dist="12700" dir="5400000">
+              <a:srgbClr val="8C99A8">
+                <a:alpha val="22000"/>
+              </a:srgbClr>
+            </a:outerShdw>
+          </a:effectLst>
+        </p:spPr>
+      </p:sp>
+      <p:sp>
+        <p:nvSpPr>
+          <p:cNvPr id="25" name="Text 23"/>
+          <p:cNvSpPr txBox="1"/>
+          <p:nvPr/>
+        </p:nvSpPr>
+        <p:spPr>
+          <a:xfrm>
+            <a:off x="713232" y="2724912"/>
+            <a:ext cx="2505456" cy="475488"/>
+          </a:xfrm>
+          <a:prstGeom prst="rect">
+            <a:avLst/>
+          </a:prstGeom>
+          <a:noFill/>
+          <a:ln/>
+        </p:spPr>
+        <p:txBody>
+          <a:bodyPr wrap="square" lIns="0" tIns="0" rIns="0" bIns="0" rtlCol="0" anchor="ctr"/>
+          <a:lstStyle/>
+          <a:p>
+            <a:pPr algn="l" indent="0" marL="0">
+              <a:lnSpc>
+                <a:spcPct val="100000"/>
+              </a:lnSpc>
+              <a:buNone/>
+            </a:pPr>
+            <a:r>
+              <a:rPr lang="en-US" sz="1100" b="1" dirty="0">
+                <a:solidFill>
+                  <a:srgbClr val="FFFFFF"/>
+                </a:solidFill>
+                <a:latin typeface="Calibri" pitchFamily="34" charset="0"/>
+                <a:ea typeface="Calibri" pitchFamily="34" charset="-122"/>
+                <a:cs typeface="Calibri" pitchFamily="34" charset="-120"/>
+              </a:rPr>
+              <a:t>Меридиан — Коммуникации</a:t>
+            </a:r>
+            <a:endParaRPr lang="en-US" sz="1100" dirty="0"/>
+          </a:p>
+        </p:txBody>
+      </p:sp>
+      <p:sp>
+        <p:nvSpPr>
+          <p:cNvPr id="26" name="Line 24"/>
+          <p:cNvSpPr/>
+          <p:nvPr/>
+        </p:nvSpPr>
+        <p:spPr>
+          <a:xfrm>
+            <a:off x="1965960" y="3200400"/>
+            <a:ext cx="0" cy="128016"/>
+          </a:xfrm>
+          <a:prstGeom prst="line">
+            <a:avLst/>
+          </a:prstGeom>
+          <a:noFill/>
+          <a:ln w="19050">
+            <a:solidFill>
+              <a:srgbClr val="0F6E7B"/>
+            </a:solidFill>
+            <a:prstDash val="solid"/>
+            <a:tailEnd type="triangle"/>
+          </a:ln>
+        </p:spPr>
+      </p:sp>
+      <p:sp>
+        <p:nvSpPr>
+          <p:cNvPr id="27" name="Shape 25"/>
+          <p:cNvSpPr/>
+          <p:nvPr/>
+        </p:nvSpPr>
+        <p:spPr>
+          <a:xfrm>
+            <a:off x="548640" y="3328416"/>
+            <a:ext cx="2834640" cy="329184"/>
+          </a:xfrm>
+          <a:prstGeom prst="roundRect">
+            <a:avLst>
+              <a:gd name="adj" fmla="val 12500"/>
+            </a:avLst>
+          </a:prstGeom>
+          <a:solidFill>
+            <a:srgbClr val="FFFFFF"/>
+          </a:solidFill>
+          <a:ln w="15875">
+            <a:solidFill>
+              <a:srgbClr val="0F6E7B"/>
+            </a:solidFill>
+            <a:prstDash val="solid"/>
+          </a:ln>
+        </p:spPr>
+      </p:sp>
+      <p:sp>
+        <p:nvSpPr>
+          <p:cNvPr id="28" name="Text 26"/>
+          <p:cNvSpPr txBox="1"/>
+          <p:nvPr/>
+        </p:nvSpPr>
+        <p:spPr>
+          <a:xfrm>
+            <a:off x="548640" y="3328416"/>
+            <a:ext cx="2834640" cy="329184"/>
+          </a:xfrm>
+          <a:prstGeom prst="rect">
+            <a:avLst/>
+          </a:prstGeom>
+          <a:noFill/>
+          <a:ln/>
+        </p:spPr>
+        <p:txBody>
+          <a:bodyPr wrap="square" lIns="0" tIns="0" rIns="0" bIns="0" rtlCol="0" anchor="ctr"/>
+          <a:lstStyle/>
+          <a:p>
+            <a:pPr algn="ctr" indent="0" marL="0">
+              <a:buNone/>
+            </a:pPr>
+            <a:r>
+              <a:rPr lang="en-US" sz="900" dirty="0">
+                <a:solidFill>
+                  <a:srgbClr val="5E6E80"/>
+                </a:solidFill>
+                <a:latin typeface="Calibri" pitchFamily="34" charset="0"/>
+                <a:ea typeface="Calibri" pitchFamily="34" charset="-122"/>
+                <a:cs typeface="Calibri" pitchFamily="34" charset="-120"/>
+              </a:rPr>
+              <a:t>коллекция  </a:t>
+            </a:r>
+            <a:r>
+              <a:rPr lang="en-US" sz="1050" b="1" dirty="0">
+                <a:solidFill>
+                  <a:srgbClr val="0F6E7B"/>
+                </a:solidFill>
+                <a:latin typeface="Courier New" pitchFamily="34" charset="0"/>
+                <a:ea typeface="Courier New" pitchFamily="34" charset="-122"/>
+                <a:cs typeface="Courier New" pitchFamily="34" charset="-120"/>
+              </a:rPr>
+              <a:t>meridian_comms</a:t>
+            </a:r>
+            <a:endParaRPr lang="en-US" sz="1050" dirty="0"/>
+          </a:p>
+        </p:txBody>
+      </p:sp>
+      <p:sp>
+        <p:nvSpPr>
+          <p:cNvPr id="29" name="Shape 27"/>
+          <p:cNvSpPr/>
+          <p:nvPr/>
+        </p:nvSpPr>
+        <p:spPr>
+          <a:xfrm>
+            <a:off x="548640" y="3931920"/>
+            <a:ext cx="2834640" cy="475488"/>
+          </a:xfrm>
+          <a:prstGeom prst="roundRect">
+            <a:avLst>
+              <a:gd name="adj" fmla="val 9615"/>
+            </a:avLst>
+          </a:prstGeom>
+          <a:solidFill>
+            <a:srgbClr val="0F6E7B"/>
+          </a:solidFill>
+          <a:ln w="12700">
+            <a:solidFill>
+              <a:srgbClr val="0F6E7B"/>
+            </a:solidFill>
+            <a:prstDash val="solid"/>
+          </a:ln>
+          <a:effectLst>
+            <a:outerShdw sx="100000" sy="100000" kx="0" ky="0" algn="bl" rotWithShape="0" blurRad="76200" dist="12700" dir="5400000">
+              <a:srgbClr val="8C99A8">
+                <a:alpha val="22000"/>
+              </a:srgbClr>
+            </a:outerShdw>
+          </a:effectLst>
+        </p:spPr>
+      </p:sp>
+      <p:sp>
+        <p:nvSpPr>
+          <p:cNvPr id="30" name="Text 28"/>
+          <p:cNvSpPr txBox="1"/>
+          <p:nvPr/>
+        </p:nvSpPr>
+        <p:spPr>
+          <a:xfrm>
+            <a:off x="713232" y="3931920"/>
+            <a:ext cx="2505456" cy="475488"/>
+          </a:xfrm>
+          <a:prstGeom prst="rect">
+            <a:avLst/>
+          </a:prstGeom>
+          <a:noFill/>
+          <a:ln/>
+        </p:spPr>
+        <p:txBody>
+          <a:bodyPr wrap="square" lIns="0" tIns="0" rIns="0" bIns="0" rtlCol="0" anchor="ctr"/>
+          <a:lstStyle/>
+          <a:p>
+            <a:pPr algn="l" indent="0" marL="0">
+              <a:lnSpc>
+                <a:spcPct val="100000"/>
+              </a:lnSpc>
+              <a:buNone/>
+            </a:pPr>
+            <a:r>
+              <a:rPr lang="en-US" sz="1100" b="1" dirty="0">
+                <a:solidFill>
+                  <a:srgbClr val="FFFFFF"/>
+                </a:solidFill>
+                <a:latin typeface="Calibri" pitchFamily="34" charset="0"/>
+                <a:ea typeface="Calibri" pitchFamily="34" charset="-122"/>
+                <a:cs typeface="Calibri" pitchFamily="34" charset="-120"/>
+              </a:rPr>
+              <a:t>Меридиан — Политики</a:t>
+            </a:r>
+            <a:endParaRPr lang="en-US" sz="1100" dirty="0"/>
+          </a:p>
+        </p:txBody>
+      </p:sp>
+      <p:sp>
+        <p:nvSpPr>
+          <p:cNvPr id="31" name="Line 29"/>
+          <p:cNvSpPr/>
+          <p:nvPr/>
+        </p:nvSpPr>
+        <p:spPr>
+          <a:xfrm>
+            <a:off x="1965960" y="4407408"/>
+            <a:ext cx="0" cy="128016"/>
+          </a:xfrm>
+          <a:prstGeom prst="line">
+            <a:avLst/>
+          </a:prstGeom>
+          <a:noFill/>
+          <a:ln w="19050">
+            <a:solidFill>
+              <a:srgbClr val="0F6E7B"/>
+            </a:solidFill>
+            <a:prstDash val="solid"/>
+            <a:tailEnd type="triangle"/>
+          </a:ln>
+        </p:spPr>
+      </p:sp>
+      <p:sp>
+        <p:nvSpPr>
+          <p:cNvPr id="32" name="Shape 30"/>
+          <p:cNvSpPr/>
+          <p:nvPr/>
+        </p:nvSpPr>
+        <p:spPr>
+          <a:xfrm>
+            <a:off x="548640" y="4535424"/>
+            <a:ext cx="2834640" cy="329184"/>
+          </a:xfrm>
+          <a:prstGeom prst="roundRect">
+            <a:avLst>
+              <a:gd name="adj" fmla="val 12500"/>
+            </a:avLst>
+          </a:prstGeom>
+          <a:solidFill>
+            <a:srgbClr val="FFFFFF"/>
+          </a:solidFill>
+          <a:ln w="15875">
+            <a:solidFill>
+              <a:srgbClr val="0F6E7B"/>
+            </a:solidFill>
+            <a:prstDash val="solid"/>
+          </a:ln>
+        </p:spPr>
+      </p:sp>
+      <p:sp>
+        <p:nvSpPr>
+          <p:cNvPr id="33" name="Text 31"/>
+          <p:cNvSpPr txBox="1"/>
+          <p:nvPr/>
+        </p:nvSpPr>
+        <p:spPr>
+          <a:xfrm>
+            <a:off x="548640" y="4535424"/>
+            <a:ext cx="2834640" cy="329184"/>
+          </a:xfrm>
+          <a:prstGeom prst="rect">
+            <a:avLst/>
+          </a:prstGeom>
+          <a:noFill/>
+          <a:ln/>
+        </p:spPr>
+        <p:txBody>
+          <a:bodyPr wrap="square" lIns="0" tIns="0" rIns="0" bIns="0" rtlCol="0" anchor="ctr"/>
+          <a:lstStyle/>
+          <a:p>
+            <a:pPr algn="ctr" indent="0" marL="0">
+              <a:buNone/>
+            </a:pPr>
+            <a:r>
+              <a:rPr lang="en-US" sz="900" dirty="0">
+                <a:solidFill>
+                  <a:srgbClr val="5E6E80"/>
+                </a:solidFill>
+                <a:latin typeface="Calibri" pitchFamily="34" charset="0"/>
+                <a:ea typeface="Calibri" pitchFamily="34" charset="-122"/>
+                <a:cs typeface="Calibri" pitchFamily="34" charset="-120"/>
+              </a:rPr>
+              <a:t>коллекция  </a:t>
+            </a:r>
+            <a:r>
+              <a:rPr lang="en-US" sz="1050" b="1" dirty="0">
+                <a:solidFill>
+                  <a:srgbClr val="0F6E7B"/>
+                </a:solidFill>
+                <a:latin typeface="Courier New" pitchFamily="34" charset="0"/>
+                <a:ea typeface="Courier New" pitchFamily="34" charset="-122"/>
+                <a:cs typeface="Courier New" pitchFamily="34" charset="-120"/>
+              </a:rPr>
+              <a:t>meridian_policies</a:t>
+            </a:r>
+            <a:endParaRPr lang="en-US" sz="1050" dirty="0"/>
+          </a:p>
+        </p:txBody>
+      </p:sp>
+      <p:sp>
+        <p:nvSpPr>
+          <p:cNvPr id="34" name="Shape 32"/>
+          <p:cNvSpPr/>
+          <p:nvPr/>
+        </p:nvSpPr>
+        <p:spPr>
+          <a:xfrm>
+            <a:off x="548640" y="5138928"/>
+            <a:ext cx="2834640" cy="475488"/>
+          </a:xfrm>
+          <a:prstGeom prst="roundRect">
+            <a:avLst>
+              <a:gd name="adj" fmla="val 9615"/>
+            </a:avLst>
+          </a:prstGeom>
+          <a:solidFill>
+            <a:srgbClr val="0F6E7B"/>
+          </a:solidFill>
+          <a:ln w="12700">
+            <a:solidFill>
+              <a:srgbClr val="0F6E7B"/>
+            </a:solidFill>
+            <a:prstDash val="solid"/>
+          </a:ln>
+          <a:effectLst>
+            <a:outerShdw sx="100000" sy="100000" kx="0" ky="0" algn="bl" rotWithShape="0" blurRad="76200" dist="12700" dir="5400000">
+              <a:srgbClr val="8C99A8">
+                <a:alpha val="22000"/>
+              </a:srgbClr>
+            </a:outerShdw>
+          </a:effectLst>
+        </p:spPr>
+      </p:sp>
+      <p:sp>
+        <p:nvSpPr>
+          <p:cNvPr id="35" name="Text 33"/>
+          <p:cNvSpPr txBox="1"/>
+          <p:nvPr/>
+        </p:nvSpPr>
+        <p:spPr>
+          <a:xfrm>
+            <a:off x="713232" y="5138928"/>
+            <a:ext cx="2505456" cy="475488"/>
+          </a:xfrm>
+          <a:prstGeom prst="rect">
+            <a:avLst/>
+          </a:prstGeom>
+          <a:noFill/>
+          <a:ln/>
+        </p:spPr>
+        <p:txBody>
+          <a:bodyPr wrap="square" lIns="0" tIns="0" rIns="0" bIns="0" rtlCol="0" anchor="ctr"/>
+          <a:lstStyle/>
+          <a:p>
+            <a:pPr algn="l" indent="0" marL="0">
+              <a:lnSpc>
+                <a:spcPct val="100000"/>
+              </a:lnSpc>
+              <a:buNone/>
+            </a:pPr>
+            <a:r>
+              <a:rPr lang="en-US" sz="1100" b="1" dirty="0">
+                <a:solidFill>
+                  <a:srgbClr val="FFFFFF"/>
+                </a:solidFill>
+                <a:latin typeface="Calibri" pitchFamily="34" charset="0"/>
+                <a:ea typeface="Calibri" pitchFamily="34" charset="-122"/>
+                <a:cs typeface="Calibri" pitchFamily="34" charset="-120"/>
+              </a:rPr>
+              <a:t>Полка — Операционные документы</a:t>
+            </a:r>
+            <a:endParaRPr lang="en-US" sz="1100" dirty="0"/>
+          </a:p>
+        </p:txBody>
+      </p:sp>
+      <p:sp>
+        <p:nvSpPr>
+          <p:cNvPr id="36" name="Line 34"/>
+          <p:cNvSpPr/>
+          <p:nvPr/>
+        </p:nvSpPr>
+        <p:spPr>
+          <a:xfrm>
+            <a:off x="1965960" y="5614416"/>
+            <a:ext cx="0" cy="128016"/>
+          </a:xfrm>
+          <a:prstGeom prst="line">
+            <a:avLst/>
+          </a:prstGeom>
+          <a:noFill/>
+          <a:ln w="19050">
+            <a:solidFill>
+              <a:srgbClr val="0F6E7B"/>
+            </a:solidFill>
+            <a:prstDash val="solid"/>
+            <a:tailEnd type="triangle"/>
+          </a:ln>
+        </p:spPr>
+      </p:sp>
+      <p:sp>
+        <p:nvSpPr>
+          <p:cNvPr id="37" name="Shape 35"/>
+          <p:cNvSpPr/>
+          <p:nvPr/>
+        </p:nvSpPr>
+        <p:spPr>
+          <a:xfrm>
+            <a:off x="548640" y="5742432"/>
+            <a:ext cx="2834640" cy="329184"/>
+          </a:xfrm>
+          <a:prstGeom prst="roundRect">
+            <a:avLst>
+              <a:gd name="adj" fmla="val 12500"/>
+            </a:avLst>
+          </a:prstGeom>
+          <a:solidFill>
+            <a:srgbClr val="FFFFFF"/>
+          </a:solidFill>
+          <a:ln w="15875">
+            <a:solidFill>
+              <a:srgbClr val="0F6E7B"/>
+            </a:solidFill>
+            <a:prstDash val="solid"/>
+          </a:ln>
+        </p:spPr>
+      </p:sp>
+      <p:sp>
+        <p:nvSpPr>
+          <p:cNvPr id="38" name="Text 36"/>
+          <p:cNvSpPr txBox="1"/>
+          <p:nvPr/>
+        </p:nvSpPr>
+        <p:spPr>
+          <a:xfrm>
+            <a:off x="548640" y="5742432"/>
+            <a:ext cx="2834640" cy="329184"/>
+          </a:xfrm>
+          <a:prstGeom prst="rect">
+            <a:avLst/>
+          </a:prstGeom>
+          <a:noFill/>
+          <a:ln/>
+        </p:spPr>
+        <p:txBody>
+          <a:bodyPr wrap="square" lIns="0" tIns="0" rIns="0" bIns="0" rtlCol="0" anchor="ctr"/>
+          <a:lstStyle/>
+          <a:p>
+            <a:pPr algn="ctr" indent="0" marL="0">
+              <a:buNone/>
+            </a:pPr>
+            <a:r>
+              <a:rPr lang="en-US" sz="900" dirty="0">
+                <a:solidFill>
+                  <a:srgbClr val="5E6E80"/>
+                </a:solidFill>
+                <a:latin typeface="Calibri" pitchFamily="34" charset="0"/>
+                <a:ea typeface="Calibri" pitchFamily="34" charset="-122"/>
+                <a:cs typeface="Calibri" pitchFamily="34" charset="-120"/>
+              </a:rPr>
+              <a:t>коллекция  </a:t>
+            </a:r>
+            <a:r>
+              <a:rPr lang="en-US" sz="1050" b="1" dirty="0">
+                <a:solidFill>
+                  <a:srgbClr val="0F6E7B"/>
+                </a:solidFill>
+                <a:latin typeface="Courier New" pitchFamily="34" charset="0"/>
+                <a:ea typeface="Courier New" pitchFamily="34" charset="-122"/>
+                <a:cs typeface="Courier New" pitchFamily="34" charset="-120"/>
+              </a:rPr>
+              <a:t>polka_docs</a:t>
+            </a:r>
+            <a:endParaRPr lang="en-US" sz="1050" dirty="0"/>
+          </a:p>
+        </p:txBody>
+      </p:sp>
+      <p:sp>
+        <p:nvSpPr>
+          <p:cNvPr id="39" name="Shape 37"/>
+          <p:cNvSpPr/>
+          <p:nvPr/>
+        </p:nvSpPr>
+        <p:spPr>
+          <a:xfrm>
+            <a:off x="7059168" y="1517904"/>
+            <a:ext cx="4581144" cy="457200"/>
+          </a:xfrm>
+          <a:prstGeom prst="roundRect">
+            <a:avLst>
+              <a:gd name="adj" fmla="val 4098"/>
+            </a:avLst>
+          </a:prstGeom>
+          <a:solidFill>
+            <a:srgbClr val="FFFFFF"/>
+          </a:solidFill>
+          <a:ln w="12700">
+            <a:solidFill>
+              <a:srgbClr val="C6D0DB"/>
+            </a:solidFill>
+            <a:prstDash val="solid"/>
+          </a:ln>
+          <a:effectLst>
+            <a:outerShdw sx="100000" sy="100000" kx="0" ky="0" algn="bl" rotWithShape="0" blurRad="76200" dist="12700" dir="5400000">
+              <a:srgbClr val="8C99A8">
+                <a:alpha val="22000"/>
+              </a:srgbClr>
+            </a:outerShdw>
+          </a:effectLst>
+        </p:spPr>
+      </p:sp>
+      <p:sp>
+        <p:nvSpPr>
+          <p:cNvPr id="40" name="Text 38"/>
+          <p:cNvSpPr txBox="1"/>
+          <p:nvPr/>
+        </p:nvSpPr>
+        <p:spPr>
+          <a:xfrm>
+            <a:off x="7260336" y="1517904"/>
+            <a:ext cx="2194560" cy="457200"/>
+          </a:xfrm>
+          <a:prstGeom prst="rect">
+            <a:avLst/>
+          </a:prstGeom>
+          <a:noFill/>
+          <a:ln/>
+        </p:spPr>
+        <p:txBody>
+          <a:bodyPr wrap="square" lIns="0" tIns="0" rIns="0" bIns="0" rtlCol="0" anchor="ctr"/>
+          <a:lstStyle/>
+          <a:p>
+            <a:pPr algn="l" indent="0" marL="0">
+              <a:buNone/>
+            </a:pPr>
+            <a:r>
+              <a:rPr lang="en-US" sz="1100" b="1" dirty="0">
+                <a:solidFill>
+                  <a:srgbClr val="16233A"/>
+                </a:solidFill>
+                <a:latin typeface="Calibri" pitchFamily="34" charset="0"/>
+                <a:ea typeface="Calibri" pitchFamily="34" charset="-122"/>
+                <a:cs typeface="Calibri" pitchFamily="34" charset="-120"/>
+              </a:rPr>
+              <a:t>Петров А.В. (E-006)</a:t>
+            </a:r>
+            <a:endParaRPr lang="en-US" sz="1100" dirty="0"/>
+          </a:p>
+        </p:txBody>
+      </p:sp>
+      <p:sp>
+        <p:nvSpPr>
+          <p:cNvPr id="41" name="Text 39"/>
+          <p:cNvSpPr txBox="1"/>
+          <p:nvPr/>
+        </p:nvSpPr>
+        <p:spPr>
+          <a:xfrm>
+            <a:off x="9528048" y="1517904"/>
+            <a:ext cx="1911096" cy="457200"/>
+          </a:xfrm>
+          <a:prstGeom prst="rect">
+            <a:avLst/>
+          </a:prstGeom>
+          <a:noFill/>
+          <a:ln/>
+        </p:spPr>
+        <p:txBody>
+          <a:bodyPr wrap="square" lIns="0" tIns="0" rIns="0" bIns="0" rtlCol="0" anchor="ctr"/>
+          <a:lstStyle/>
+          <a:p>
+            <a:pPr algn="r" indent="0" marL="0">
+              <a:buNone/>
+            </a:pPr>
+            <a:r>
+              <a:rPr lang="en-US" sz="900" b="1" dirty="0">
+                <a:solidFill>
+                  <a:srgbClr val="A96412"/>
+                </a:solidFill>
+                <a:latin typeface="Calibri" pitchFamily="34" charset="0"/>
+                <a:ea typeface="Calibri" pitchFamily="34" charset="-122"/>
+                <a:cs typeface="Calibri" pitchFamily="34" charset="-120"/>
+              </a:rPr>
+              <a:t>Меридиан-Рук-продаж</a:t>
+            </a:r>
+            <a:endParaRPr lang="en-US" sz="900" dirty="0"/>
+          </a:p>
+        </p:txBody>
+      </p:sp>
+      <p:sp>
+        <p:nvSpPr>
+          <p:cNvPr id="42" name="Shape 40"/>
+          <p:cNvSpPr/>
+          <p:nvPr/>
+        </p:nvSpPr>
+        <p:spPr>
+          <a:xfrm>
+            <a:off x="7059168" y="2103120"/>
+            <a:ext cx="4581144" cy="457200"/>
+          </a:xfrm>
+          <a:prstGeom prst="roundRect">
+            <a:avLst>
+              <a:gd name="adj" fmla="val 4098"/>
+            </a:avLst>
+          </a:prstGeom>
+          <a:solidFill>
+            <a:srgbClr val="FFFFFF"/>
+          </a:solidFill>
+          <a:ln w="12700">
+            <a:solidFill>
+              <a:srgbClr val="C6D0DB"/>
+            </a:solidFill>
+            <a:prstDash val="solid"/>
+          </a:ln>
+          <a:effectLst>
+            <a:outerShdw sx="100000" sy="100000" kx="0" ky="0" algn="bl" rotWithShape="0" blurRad="76200" dist="12700" dir="5400000">
+              <a:srgbClr val="8C99A8">
+                <a:alpha val="22000"/>
+              </a:srgbClr>
+            </a:outerShdw>
+          </a:effectLst>
+        </p:spPr>
+      </p:sp>
+      <p:sp>
+        <p:nvSpPr>
+          <p:cNvPr id="43" name="Text 41"/>
+          <p:cNvSpPr txBox="1"/>
+          <p:nvPr/>
+        </p:nvSpPr>
+        <p:spPr>
+          <a:xfrm>
+            <a:off x="7260336" y="2103120"/>
+            <a:ext cx="2194560" cy="457200"/>
+          </a:xfrm>
+          <a:prstGeom prst="rect">
+            <a:avLst/>
+          </a:prstGeom>
+          <a:noFill/>
+          <a:ln/>
+        </p:spPr>
+        <p:txBody>
+          <a:bodyPr wrap="square" lIns="0" tIns="0" rIns="0" bIns="0" rtlCol="0" anchor="ctr"/>
+          <a:lstStyle/>
+          <a:p>
+            <a:pPr algn="l" indent="0" marL="0">
+              <a:buNone/>
+            </a:pPr>
+            <a:r>
+              <a:rPr lang="en-US" sz="1100" b="1" dirty="0">
+                <a:solidFill>
+                  <a:srgbClr val="16233A"/>
+                </a:solidFill>
+                <a:latin typeface="Calibri" pitchFamily="34" charset="0"/>
+                <a:ea typeface="Calibri" pitchFamily="34" charset="-122"/>
+                <a:cs typeface="Calibri" pitchFamily="34" charset="-120"/>
+              </a:rPr>
+              <a:t>Иванова Т.Н. (E-003)</a:t>
+            </a:r>
+            <a:endParaRPr lang="en-US" sz="1100" dirty="0"/>
+          </a:p>
+        </p:txBody>
+      </p:sp>
+      <p:sp>
+        <p:nvSpPr>
+          <p:cNvPr id="44" name="Text 42"/>
+          <p:cNvSpPr txBox="1"/>
+          <p:nvPr/>
+        </p:nvSpPr>
+        <p:spPr>
+          <a:xfrm>
+            <a:off x="9528048" y="2103120"/>
+            <a:ext cx="1911096" cy="457200"/>
+          </a:xfrm>
+          <a:prstGeom prst="rect">
+            <a:avLst/>
+          </a:prstGeom>
+          <a:noFill/>
+          <a:ln/>
+        </p:spPr>
+        <p:txBody>
+          <a:bodyPr wrap="square" lIns="0" tIns="0" rIns="0" bIns="0" rtlCol="0" anchor="ctr"/>
+          <a:lstStyle/>
+          <a:p>
+            <a:pPr algn="r" indent="0" marL="0">
+              <a:buNone/>
+            </a:pPr>
+            <a:r>
+              <a:rPr lang="en-US" sz="900" b="1" dirty="0">
+                <a:solidFill>
+                  <a:srgbClr val="A96412"/>
+                </a:solidFill>
+                <a:latin typeface="Calibri" pitchFamily="34" charset="0"/>
+                <a:ea typeface="Calibri" pitchFamily="34" charset="-122"/>
+                <a:cs typeface="Calibri" pitchFamily="34" charset="-120"/>
+              </a:rPr>
+              <a:t>Меридиан-HR-директор</a:t>
+            </a:r>
+            <a:endParaRPr lang="en-US" sz="900" dirty="0"/>
+          </a:p>
+        </p:txBody>
+      </p:sp>
+      <p:sp>
+        <p:nvSpPr>
+          <p:cNvPr id="45" name="Shape 43"/>
+          <p:cNvSpPr/>
+          <p:nvPr/>
+        </p:nvSpPr>
+        <p:spPr>
+          <a:xfrm>
+            <a:off x="7059168" y="2688336"/>
+            <a:ext cx="4581144" cy="457200"/>
+          </a:xfrm>
+          <a:prstGeom prst="roundRect">
+            <a:avLst>
+              <a:gd name="adj" fmla="val 4098"/>
+            </a:avLst>
+          </a:prstGeom>
+          <a:solidFill>
+            <a:srgbClr val="FFFFFF"/>
+          </a:solidFill>
+          <a:ln w="12700">
+            <a:solidFill>
+              <a:srgbClr val="C6D0DB"/>
+            </a:solidFill>
+            <a:prstDash val="solid"/>
+          </a:ln>
+          <a:effectLst>
+            <a:outerShdw sx="100000" sy="100000" kx="0" ky="0" algn="bl" rotWithShape="0" blurRad="76200" dist="12700" dir="5400000">
+              <a:srgbClr val="8C99A8">
+                <a:alpha val="22000"/>
+              </a:srgbClr>
+            </a:outerShdw>
+          </a:effectLst>
+        </p:spPr>
+      </p:sp>
+      <p:sp>
+        <p:nvSpPr>
+          <p:cNvPr id="46" name="Text 44"/>
+          <p:cNvSpPr txBox="1"/>
+          <p:nvPr/>
+        </p:nvSpPr>
+        <p:spPr>
+          <a:xfrm>
+            <a:off x="7260336" y="2688336"/>
+            <a:ext cx="2194560" cy="457200"/>
+          </a:xfrm>
+          <a:prstGeom prst="rect">
+            <a:avLst/>
+          </a:prstGeom>
+          <a:noFill/>
+          <a:ln/>
+        </p:spPr>
+        <p:txBody>
+          <a:bodyPr wrap="square" lIns="0" tIns="0" rIns="0" bIns="0" rtlCol="0" anchor="ctr"/>
+          <a:lstStyle/>
+          <a:p>
+            <a:pPr algn="l" indent="0" marL="0">
+              <a:buNone/>
+            </a:pPr>
+            <a:r>
+              <a:rPr lang="en-US" sz="1100" b="1" dirty="0">
+                <a:solidFill>
+                  <a:srgbClr val="16233A"/>
+                </a:solidFill>
+                <a:latin typeface="Calibri" pitchFamily="34" charset="0"/>
+                <a:ea typeface="Calibri" pitchFamily="34" charset="-122"/>
+                <a:cs typeface="Calibri" pitchFamily="34" charset="-120"/>
+              </a:rPr>
+              <a:t>Смирнов Г.А. (E-001)</a:t>
+            </a:r>
+            <a:endParaRPr lang="en-US" sz="1100" dirty="0"/>
+          </a:p>
+        </p:txBody>
+      </p:sp>
+      <p:sp>
+        <p:nvSpPr>
+          <p:cNvPr id="47" name="Text 45"/>
+          <p:cNvSpPr txBox="1"/>
+          <p:nvPr/>
+        </p:nvSpPr>
+        <p:spPr>
+          <a:xfrm>
+            <a:off x="9528048" y="2688336"/>
+            <a:ext cx="1911096" cy="457200"/>
+          </a:xfrm>
+          <a:prstGeom prst="rect">
+            <a:avLst/>
+          </a:prstGeom>
+          <a:noFill/>
+          <a:ln/>
+        </p:spPr>
+        <p:txBody>
+          <a:bodyPr wrap="square" lIns="0" tIns="0" rIns="0" bIns="0" rtlCol="0" anchor="ctr"/>
+          <a:lstStyle/>
+          <a:p>
+            <a:pPr algn="r" indent="0" marL="0">
+              <a:buNone/>
+            </a:pPr>
+            <a:r>
+              <a:rPr lang="en-US" sz="900" b="1" dirty="0">
+                <a:solidFill>
+                  <a:srgbClr val="A96412"/>
+                </a:solidFill>
+                <a:latin typeface="Calibri" pitchFamily="34" charset="0"/>
+                <a:ea typeface="Calibri" pitchFamily="34" charset="-122"/>
+                <a:cs typeface="Calibri" pitchFamily="34" charset="-120"/>
+              </a:rPr>
+              <a:t>Меридиан-Гендиректор</a:t>
+            </a:r>
+            <a:endParaRPr lang="en-US" sz="900" dirty="0"/>
+          </a:p>
+        </p:txBody>
+      </p:sp>
+      <p:sp>
+        <p:nvSpPr>
+          <p:cNvPr id="48" name="Shape 46"/>
+          <p:cNvSpPr/>
+          <p:nvPr/>
+        </p:nvSpPr>
+        <p:spPr>
+          <a:xfrm>
+            <a:off x="7059168" y="3273552"/>
+            <a:ext cx="4581144" cy="457200"/>
+          </a:xfrm>
+          <a:prstGeom prst="roundRect">
+            <a:avLst>
+              <a:gd name="adj" fmla="val 4098"/>
+            </a:avLst>
+          </a:prstGeom>
+          <a:solidFill>
+            <a:srgbClr val="FFFFFF"/>
+          </a:solidFill>
+          <a:ln w="12700">
+            <a:solidFill>
+              <a:srgbClr val="C6D0DB"/>
+            </a:solidFill>
+            <a:prstDash val="solid"/>
+          </a:ln>
+          <a:effectLst>
+            <a:outerShdw sx="100000" sy="100000" kx="0" ky="0" algn="bl" rotWithShape="0" blurRad="76200" dist="12700" dir="5400000">
+              <a:srgbClr val="8C99A8">
+                <a:alpha val="22000"/>
+              </a:srgbClr>
+            </a:outerShdw>
+          </a:effectLst>
+        </p:spPr>
+      </p:sp>
+      <p:sp>
+        <p:nvSpPr>
+          <p:cNvPr id="49" name="Text 47"/>
+          <p:cNvSpPr txBox="1"/>
+          <p:nvPr/>
+        </p:nvSpPr>
+        <p:spPr>
+          <a:xfrm>
+            <a:off x="7260336" y="3273552"/>
+            <a:ext cx="2194560" cy="457200"/>
+          </a:xfrm>
+          <a:prstGeom prst="rect">
+            <a:avLst/>
+          </a:prstGeom>
+          <a:noFill/>
+          <a:ln/>
+        </p:spPr>
+        <p:txBody>
+          <a:bodyPr wrap="square" lIns="0" tIns="0" rIns="0" bIns="0" rtlCol="0" anchor="ctr"/>
+          <a:lstStyle/>
+          <a:p>
+            <a:pPr algn="l" indent="0" marL="0">
+              <a:buNone/>
+            </a:pPr>
+            <a:r>
+              <a:rPr lang="en-US" sz="1100" b="1" dirty="0">
+                <a:solidFill>
+                  <a:srgbClr val="16233A"/>
+                </a:solidFill>
+                <a:latin typeface="Calibri" pitchFamily="34" charset="0"/>
+                <a:ea typeface="Calibri" pitchFamily="34" charset="-122"/>
+                <a:cs typeface="Calibri" pitchFamily="34" charset="-120"/>
+              </a:rPr>
+              <a:t>Кузнецова А.Д. (E-005)</a:t>
+            </a:r>
+            <a:endParaRPr lang="en-US" sz="1100" dirty="0"/>
+          </a:p>
+        </p:txBody>
+      </p:sp>
+      <p:sp>
+        <p:nvSpPr>
+          <p:cNvPr id="50" name="Text 48"/>
+          <p:cNvSpPr txBox="1"/>
+          <p:nvPr/>
+        </p:nvSpPr>
+        <p:spPr>
+          <a:xfrm>
+            <a:off x="9528048" y="3273552"/>
+            <a:ext cx="1911096" cy="457200"/>
+          </a:xfrm>
+          <a:prstGeom prst="rect">
+            <a:avLst/>
+          </a:prstGeom>
+          <a:noFill/>
+          <a:ln/>
+        </p:spPr>
+        <p:txBody>
+          <a:bodyPr wrap="square" lIns="0" tIns="0" rIns="0" bIns="0" rtlCol="0" anchor="ctr"/>
+          <a:lstStyle/>
+          <a:p>
+            <a:pPr algn="r" indent="0" marL="0">
+              <a:buNone/>
+            </a:pPr>
+            <a:r>
+              <a:rPr lang="en-US" sz="900" b="1" dirty="0">
+                <a:solidFill>
+                  <a:srgbClr val="A96412"/>
+                </a:solidFill>
+                <a:latin typeface="Calibri" pitchFamily="34" charset="0"/>
+                <a:ea typeface="Calibri" pitchFamily="34" charset="-122"/>
+                <a:cs typeface="Calibri" pitchFamily="34" charset="-120"/>
+              </a:rPr>
+              <a:t>Меридиан-Юрист</a:t>
+            </a:r>
+            <a:endParaRPr lang="en-US" sz="900" dirty="0"/>
+          </a:p>
+        </p:txBody>
+      </p:sp>
+      <p:sp>
+        <p:nvSpPr>
+          <p:cNvPr id="51" name="Shape 49"/>
+          <p:cNvSpPr/>
+          <p:nvPr/>
+        </p:nvSpPr>
+        <p:spPr>
+          <a:xfrm>
+            <a:off x="7059168" y="3858768"/>
+            <a:ext cx="4581144" cy="457200"/>
+          </a:xfrm>
+          <a:prstGeom prst="roundRect">
+            <a:avLst>
+              <a:gd name="adj" fmla="val 4098"/>
+            </a:avLst>
+          </a:prstGeom>
+          <a:solidFill>
+            <a:srgbClr val="FFFFFF"/>
+          </a:solidFill>
+          <a:ln w="12700">
+            <a:solidFill>
+              <a:srgbClr val="C6D0DB"/>
+            </a:solidFill>
+            <a:prstDash val="solid"/>
+          </a:ln>
+          <a:effectLst>
+            <a:outerShdw sx="100000" sy="100000" kx="0" ky="0" algn="bl" rotWithShape="0" blurRad="76200" dist="12700" dir="5400000">
+              <a:srgbClr val="8C99A8">
+                <a:alpha val="22000"/>
+              </a:srgbClr>
+            </a:outerShdw>
+          </a:effectLst>
+        </p:spPr>
+      </p:sp>
+      <p:sp>
+        <p:nvSpPr>
+          <p:cNvPr id="52" name="Text 50"/>
+          <p:cNvSpPr txBox="1"/>
+          <p:nvPr/>
+        </p:nvSpPr>
+        <p:spPr>
+          <a:xfrm>
+            <a:off x="7260336" y="3858768"/>
+            <a:ext cx="2194560" cy="457200"/>
+          </a:xfrm>
+          <a:prstGeom prst="rect">
+            <a:avLst/>
+          </a:prstGeom>
+          <a:noFill/>
+          <a:ln/>
+        </p:spPr>
+        <p:txBody>
+          <a:bodyPr wrap="square" lIns="0" tIns="0" rIns="0" bIns="0" rtlCol="0" anchor="ctr"/>
+          <a:lstStyle/>
+          <a:p>
+            <a:pPr algn="l" indent="0" marL="0">
+              <a:buNone/>
+            </a:pPr>
+            <a:r>
+              <a:rPr lang="en-US" sz="1100" b="1" dirty="0">
+                <a:solidFill>
+                  <a:srgbClr val="16233A"/>
+                </a:solidFill>
+                <a:latin typeface="Calibri" pitchFamily="34" charset="0"/>
+                <a:ea typeface="Calibri" pitchFamily="34" charset="-122"/>
+                <a:cs typeface="Calibri" pitchFamily="34" charset="-120"/>
+              </a:rPr>
+              <a:t>Сидоров К.Л. (E-011)</a:t>
+            </a:r>
+            <a:endParaRPr lang="en-US" sz="1100" dirty="0"/>
+          </a:p>
+        </p:txBody>
+      </p:sp>
+      <p:sp>
+        <p:nvSpPr>
+          <p:cNvPr id="53" name="Text 51"/>
+          <p:cNvSpPr txBox="1"/>
+          <p:nvPr/>
+        </p:nvSpPr>
+        <p:spPr>
+          <a:xfrm>
+            <a:off x="9528048" y="3858768"/>
+            <a:ext cx="1911096" cy="457200"/>
+          </a:xfrm>
+          <a:prstGeom prst="rect">
+            <a:avLst/>
+          </a:prstGeom>
+          <a:noFill/>
+          <a:ln/>
+        </p:spPr>
+        <p:txBody>
+          <a:bodyPr wrap="square" lIns="0" tIns="0" rIns="0" bIns="0" rtlCol="0" anchor="ctr"/>
+          <a:lstStyle/>
+          <a:p>
+            <a:pPr algn="r" indent="0" marL="0">
+              <a:buNone/>
+            </a:pPr>
+            <a:r>
+              <a:rPr lang="en-US" sz="900" b="1" dirty="0">
+                <a:solidFill>
+                  <a:srgbClr val="A96412"/>
+                </a:solidFill>
+                <a:latin typeface="Calibri" pitchFamily="34" charset="0"/>
+                <a:ea typeface="Calibri" pitchFamily="34" charset="-122"/>
+                <a:cs typeface="Calibri" pitchFamily="34" charset="-120"/>
+              </a:rPr>
+              <a:t>Меридиан-Финаналитик</a:t>
+            </a:r>
+            <a:endParaRPr lang="en-US" sz="900" dirty="0"/>
+          </a:p>
+        </p:txBody>
+      </p:sp>
+      <p:sp>
+        <p:nvSpPr>
+          <p:cNvPr id="54" name="Shape 52"/>
+          <p:cNvSpPr/>
+          <p:nvPr/>
+        </p:nvSpPr>
+        <p:spPr>
+          <a:xfrm>
+            <a:off x="7059168" y="4443984"/>
+            <a:ext cx="4581144" cy="457200"/>
+          </a:xfrm>
+          <a:prstGeom prst="roundRect">
+            <a:avLst>
+              <a:gd name="adj" fmla="val 4098"/>
+            </a:avLst>
+          </a:prstGeom>
+          <a:solidFill>
+            <a:srgbClr val="FFFFFF"/>
+          </a:solidFill>
+          <a:ln w="12700">
+            <a:solidFill>
+              <a:srgbClr val="C6D0DB"/>
+            </a:solidFill>
+            <a:prstDash val="solid"/>
+          </a:ln>
+          <a:effectLst>
+            <a:outerShdw sx="100000" sy="100000" kx="0" ky="0" algn="bl" rotWithShape="0" blurRad="76200" dist="12700" dir="5400000">
+              <a:srgbClr val="8C99A8">
+                <a:alpha val="22000"/>
+              </a:srgbClr>
+            </a:outerShdw>
+          </a:effectLst>
+        </p:spPr>
+      </p:sp>
+      <p:sp>
+        <p:nvSpPr>
+          <p:cNvPr id="55" name="Text 53"/>
+          <p:cNvSpPr txBox="1"/>
+          <p:nvPr/>
+        </p:nvSpPr>
+        <p:spPr>
+          <a:xfrm>
+            <a:off x="7260336" y="4443984"/>
+            <a:ext cx="2194560" cy="457200"/>
+          </a:xfrm>
+          <a:prstGeom prst="rect">
+            <a:avLst/>
+          </a:prstGeom>
+          <a:noFill/>
+          <a:ln/>
+        </p:spPr>
+        <p:txBody>
+          <a:bodyPr wrap="square" lIns="0" tIns="0" rIns="0" bIns="0" rtlCol="0" anchor="ctr"/>
+          <a:lstStyle/>
+          <a:p>
+            <a:pPr algn="l" indent="0" marL="0">
+              <a:buNone/>
+            </a:pPr>
+            <a:r>
+              <a:rPr lang="en-US" sz="1100" b="1" dirty="0">
+                <a:solidFill>
+                  <a:srgbClr val="16233A"/>
+                </a:solidFill>
+                <a:latin typeface="Calibri" pitchFamily="34" charset="0"/>
+                <a:ea typeface="Calibri" pitchFamily="34" charset="-122"/>
+                <a:cs typeface="Calibri" pitchFamily="34" charset="-120"/>
+              </a:rPr>
+              <a:t>Соколов И.Р. (E-004)</a:t>
+            </a:r>
+            <a:endParaRPr lang="en-US" sz="1100" dirty="0"/>
+          </a:p>
+        </p:txBody>
+      </p:sp>
+      <p:sp>
+        <p:nvSpPr>
+          <p:cNvPr id="56" name="Text 54"/>
+          <p:cNvSpPr txBox="1"/>
+          <p:nvPr/>
+        </p:nvSpPr>
+        <p:spPr>
+          <a:xfrm>
+            <a:off x="9528048" y="4443984"/>
+            <a:ext cx="1911096" cy="457200"/>
+          </a:xfrm>
+          <a:prstGeom prst="rect">
+            <a:avLst/>
+          </a:prstGeom>
+          <a:noFill/>
+          <a:ln/>
+        </p:spPr>
+        <p:txBody>
+          <a:bodyPr wrap="square" lIns="0" tIns="0" rIns="0" bIns="0" rtlCol="0" anchor="ctr"/>
+          <a:lstStyle/>
+          <a:p>
+            <a:pPr algn="r" indent="0" marL="0">
+              <a:buNone/>
+            </a:pPr>
+            <a:r>
+              <a:rPr lang="en-US" sz="900" b="1" dirty="0">
+                <a:solidFill>
+                  <a:srgbClr val="A96412"/>
+                </a:solidFill>
+                <a:latin typeface="Calibri" pitchFamily="34" charset="0"/>
+                <a:ea typeface="Calibri" pitchFamily="34" charset="-122"/>
+                <a:cs typeface="Calibri" pitchFamily="34" charset="-120"/>
+              </a:rPr>
+              <a:t>Меридиан-ИБ</a:t>
+            </a:r>
+            <a:endParaRPr lang="en-US" sz="900" dirty="0"/>
+          </a:p>
+        </p:txBody>
+      </p:sp>
+      <p:sp>
+        <p:nvSpPr>
+          <p:cNvPr id="57" name="Shape 55"/>
+          <p:cNvSpPr/>
+          <p:nvPr/>
+        </p:nvSpPr>
+        <p:spPr>
+          <a:xfrm>
+            <a:off x="7059168" y="5029200"/>
+            <a:ext cx="4581144" cy="457200"/>
+          </a:xfrm>
+          <a:prstGeom prst="roundRect">
+            <a:avLst>
+              <a:gd name="adj" fmla="val 4098"/>
+            </a:avLst>
+          </a:prstGeom>
+          <a:solidFill>
+            <a:srgbClr val="FFFFFF"/>
+          </a:solidFill>
+          <a:ln w="12700">
+            <a:solidFill>
+              <a:srgbClr val="C6D0DB"/>
+            </a:solidFill>
+            <a:prstDash val="solid"/>
+          </a:ln>
+          <a:effectLst>
+            <a:outerShdw sx="100000" sy="100000" kx="0" ky="0" algn="bl" rotWithShape="0" blurRad="76200" dist="12700" dir="5400000">
+              <a:srgbClr val="8C99A8">
+                <a:alpha val="22000"/>
+              </a:srgbClr>
+            </a:outerShdw>
+          </a:effectLst>
+        </p:spPr>
+      </p:sp>
+      <p:sp>
+        <p:nvSpPr>
+          <p:cNvPr id="58" name="Text 56"/>
+          <p:cNvSpPr txBox="1"/>
+          <p:nvPr/>
+        </p:nvSpPr>
+        <p:spPr>
+          <a:xfrm>
+            <a:off x="7260336" y="5029200"/>
+            <a:ext cx="2194560" cy="457200"/>
+          </a:xfrm>
+          <a:prstGeom prst="rect">
+            <a:avLst/>
+          </a:prstGeom>
+          <a:noFill/>
+          <a:ln/>
+        </p:spPr>
+        <p:txBody>
+          <a:bodyPr wrap="square" lIns="0" tIns="0" rIns="0" bIns="0" rtlCol="0" anchor="ctr"/>
+          <a:lstStyle/>
+          <a:p>
+            <a:pPr algn="l" indent="0" marL="0">
+              <a:buNone/>
+            </a:pPr>
+            <a:r>
+              <a:rPr lang="en-US" sz="1100" b="1" dirty="0">
+                <a:solidFill>
+                  <a:srgbClr val="16233A"/>
+                </a:solidFill>
+                <a:latin typeface="Calibri" pitchFamily="34" charset="0"/>
+                <a:ea typeface="Calibri" pitchFamily="34" charset="-122"/>
+                <a:cs typeface="Calibri" pitchFamily="34" charset="-120"/>
+              </a:rPr>
+              <a:t>клиентский сервис</a:t>
+            </a:r>
+            <a:endParaRPr lang="en-US" sz="1100" dirty="0"/>
+          </a:p>
+        </p:txBody>
+      </p:sp>
+      <p:sp>
+        <p:nvSpPr>
+          <p:cNvPr id="59" name="Text 57"/>
+          <p:cNvSpPr txBox="1"/>
+          <p:nvPr/>
+        </p:nvSpPr>
+        <p:spPr>
+          <a:xfrm>
+            <a:off x="9528048" y="5029200"/>
+            <a:ext cx="1911096" cy="457200"/>
+          </a:xfrm>
+          <a:prstGeom prst="rect">
+            <a:avLst/>
+          </a:prstGeom>
+          <a:noFill/>
+          <a:ln/>
+        </p:spPr>
+        <p:txBody>
+          <a:bodyPr wrap="square" lIns="0" tIns="0" rIns="0" bIns="0" rtlCol="0" anchor="ctr"/>
+          <a:lstStyle/>
+          <a:p>
+            <a:pPr algn="r" indent="0" marL="0">
+              <a:buNone/>
+            </a:pPr>
+            <a:r>
+              <a:rPr lang="en-US" sz="900" b="1" dirty="0">
+                <a:solidFill>
+                  <a:srgbClr val="A96412"/>
+                </a:solidFill>
+                <a:latin typeface="Calibri" pitchFamily="34" charset="0"/>
+                <a:ea typeface="Calibri" pitchFamily="34" charset="-122"/>
+                <a:cs typeface="Calibri" pitchFamily="34" charset="-120"/>
+              </a:rPr>
+              <a:t>Полка-Сервис</a:t>
+            </a:r>
+            <a:endParaRPr lang="en-US" sz="900" dirty="0"/>
+          </a:p>
+        </p:txBody>
+      </p:sp>
+      <p:sp>
+        <p:nvSpPr>
+          <p:cNvPr id="60" name="Shape 58"/>
+          <p:cNvSpPr/>
+          <p:nvPr/>
+        </p:nvSpPr>
+        <p:spPr>
+          <a:xfrm>
+            <a:off x="7059168" y="5614416"/>
+            <a:ext cx="4581144" cy="457200"/>
+          </a:xfrm>
+          <a:prstGeom prst="roundRect">
+            <a:avLst>
+              <a:gd name="adj" fmla="val 4098"/>
+            </a:avLst>
+          </a:prstGeom>
+          <a:solidFill>
+            <a:srgbClr val="FFFFFF"/>
+          </a:solidFill>
+          <a:ln w="12700">
+            <a:solidFill>
+              <a:srgbClr val="C6D0DB"/>
+            </a:solidFill>
+            <a:prstDash val="solid"/>
+          </a:ln>
+          <a:effectLst>
+            <a:outerShdw sx="100000" sy="100000" kx="0" ky="0" algn="bl" rotWithShape="0" blurRad="76200" dist="12700" dir="5400000">
+              <a:srgbClr val="8C99A8">
+                <a:alpha val="22000"/>
+              </a:srgbClr>
+            </a:outerShdw>
+          </a:effectLst>
+        </p:spPr>
+      </p:sp>
+      <p:sp>
+        <p:nvSpPr>
+          <p:cNvPr id="61" name="Text 59"/>
+          <p:cNvSpPr txBox="1"/>
+          <p:nvPr/>
+        </p:nvSpPr>
+        <p:spPr>
+          <a:xfrm>
+            <a:off x="7260336" y="5614416"/>
+            <a:ext cx="2194560" cy="457200"/>
+          </a:xfrm>
+          <a:prstGeom prst="rect">
+            <a:avLst/>
+          </a:prstGeom>
+          <a:noFill/>
+          <a:ln/>
+        </p:spPr>
+        <p:txBody>
+          <a:bodyPr wrap="square" lIns="0" tIns="0" rIns="0" bIns="0" rtlCol="0" anchor="ctr"/>
+          <a:lstStyle/>
+          <a:p>
+            <a:pPr algn="l" indent="0" marL="0">
+              <a:buNone/>
+            </a:pPr>
+            <a:r>
+              <a:rPr lang="en-US" sz="1100" b="1" dirty="0">
+                <a:solidFill>
+                  <a:srgbClr val="16233A"/>
+                </a:solidFill>
+                <a:latin typeface="Calibri" pitchFamily="34" charset="0"/>
+                <a:ea typeface="Calibri" pitchFamily="34" charset="-122"/>
+                <a:cs typeface="Calibri" pitchFamily="34" charset="-120"/>
+              </a:rPr>
+              <a:t>категорийный менеджер</a:t>
+            </a:r>
+            <a:endParaRPr lang="en-US" sz="1100" dirty="0"/>
+          </a:p>
+        </p:txBody>
+      </p:sp>
+      <p:sp>
+        <p:nvSpPr>
+          <p:cNvPr id="62" name="Text 60"/>
+          <p:cNvSpPr txBox="1"/>
+          <p:nvPr/>
+        </p:nvSpPr>
+        <p:spPr>
+          <a:xfrm>
+            <a:off x="9528048" y="5614416"/>
+            <a:ext cx="1911096" cy="457200"/>
+          </a:xfrm>
+          <a:prstGeom prst="rect">
+            <a:avLst/>
+          </a:prstGeom>
+          <a:noFill/>
+          <a:ln/>
+        </p:spPr>
+        <p:txBody>
+          <a:bodyPr wrap="square" lIns="0" tIns="0" rIns="0" bIns="0" rtlCol="0" anchor="ctr"/>
+          <a:lstStyle/>
+          <a:p>
+            <a:pPr algn="r" indent="0" marL="0">
+              <a:buNone/>
+            </a:pPr>
+            <a:r>
+              <a:rPr lang="en-US" sz="900" b="1" dirty="0">
+                <a:solidFill>
+                  <a:srgbClr val="A96412"/>
+                </a:solidFill>
+                <a:latin typeface="Calibri" pitchFamily="34" charset="0"/>
+                <a:ea typeface="Calibri" pitchFamily="34" charset="-122"/>
+                <a:cs typeface="Calibri" pitchFamily="34" charset="-120"/>
+              </a:rPr>
+              <a:t>Полка-Продукт</a:t>
+            </a:r>
+            <a:endParaRPr lang="en-US" sz="900" dirty="0"/>
+          </a:p>
+        </p:txBody>
+      </p:sp>
+      <p:sp>
+        <p:nvSpPr>
+          <p:cNvPr id="63" name="Text 61"/>
+          <p:cNvSpPr txBox="1"/>
+          <p:nvPr/>
+        </p:nvSpPr>
+        <p:spPr>
+          <a:xfrm>
+            <a:off x="548640" y="6272784"/>
+            <a:ext cx="11091672" cy="201168"/>
+          </a:xfrm>
+          <a:prstGeom prst="rect">
+            <a:avLst/>
+          </a:prstGeom>
+          <a:noFill/>
+          <a:ln/>
+        </p:spPr>
+        <p:txBody>
+          <a:bodyPr wrap="square" lIns="0" tIns="0" rIns="0" bIns="0" rtlCol="0" anchor="t"/>
+          <a:lstStyle/>
+          <a:p>
+            <a:pPr algn="l" indent="0" marL="0">
+              <a:buNone/>
+            </a:pPr>
+            <a:r>
+              <a:rPr lang="en-US" sz="950" dirty="0">
+                <a:solidFill>
+                  <a:srgbClr val="5E6E80"/>
+                </a:solidFill>
+                <a:latin typeface="Calibri" pitchFamily="34" charset="0"/>
+                <a:ea typeface="Calibri" pitchFamily="34" charset="-122"/>
+                <a:cs typeface="Calibri" pitchFamily="34" charset="-120"/>
+              </a:rPr>
+              <a:t>Линия = домен, который персона этого пользователя включает в доступ; сами персоны, row-фильтры и маски разбираются на следующих слайдах.</a:t>
+            </a:r>
+            <a:endParaRPr lang="en-US" sz="950" dirty="0"/>
+          </a:p>
+        </p:txBody>
+      </p:sp>
+    </p:spTree>
+  </p:cSld>
+  <p:clrMapOvr>
+    <a:masterClrMapping/>
+  </p:clrMapOvr>
+</p:sld>
+</file>
+
 <file path=ppt/slides/slide2.xml><?xml version="1.0" encoding="utf-8"?>
 <p:sld xmlns:a="http://schemas.openxmlformats.org/drawingml/2006/main" xmlns:r="http://schemas.openxmlformats.org/officeDocument/2006/relationships" xmlns:p="http://schemas.openxmlformats.org/presentationml/2006/main">
   <p:cSld name="Slide 2">

</xml_diff>